<commit_message>
Atualiza slides TP06 — Assistente de Acessibilidade
</commit_message>
<xml_diff>
--- a/TP06 — Assistente de Acessibilidade.pptx
+++ b/TP06 — Assistente de Acessibilidade.pptx
@@ -13,9 +13,11 @@
     <p:sldId id="261" r:id="rId7"/>
     <p:sldId id="262" r:id="rId8"/>
     <p:sldId id="263" r:id="rId9"/>
+    <p:sldId id="264" r:id="rId10"/>
+    <p:sldId id="265" r:id="rId11"/>
   </p:sldIdLst>
   <p:notesMasterIdLst>
-    <p:notesMasterId r:id="rId10"/>
+    <p:notesMasterId r:id="rId12"/>
   </p:notesMasterIdLst>
   <p:sldSz cx="12192000" cy="6858000"/>
   <p:notesSz cx="6858000" cy="12192000"/>
@@ -551,6 +553,94 @@
 </p:notes>
 </file>
 
+<file path=ppt/notesSlides/notesSlide10.xml><?xml version="1.0" encoding="utf-8"?>
+<p:notes xmlns:a="http://schemas.openxmlformats.org/drawingml/2006/main" xmlns:r="http://schemas.openxmlformats.org/officeDocument/2006/relationships" xmlns:p="http://schemas.openxmlformats.org/presentationml/2006/main">
+  <p:cSld>
+    <p:spTree>
+      <p:nvGrpSpPr>
+        <p:cNvPr id="1" name=""/>
+        <p:cNvGrpSpPr/>
+        <p:nvPr/>
+      </p:nvGrpSpPr>
+      <p:grpSpPr>
+        <a:xfrm>
+          <a:off x="0" y="0"/>
+          <a:ext cx="0" cy="0"/>
+          <a:chOff x="0" y="0"/>
+          <a:chExt cx="0" cy="0"/>
+        </a:xfrm>
+      </p:grpSpPr>
+      <p:sp>
+        <p:nvSpPr>
+          <p:cNvPr id="2" name="Slide Image Placeholder 1"/>
+          <p:cNvSpPr>
+            <a:spLocks noGrp="1" noRot="1" noChangeAspect="1"/>
+          </p:cNvSpPr>
+          <p:nvPr>
+            <p:ph type="sldImg"/>
+          </p:nvPr>
+        </p:nvSpPr>
+        <p:spPr/>
+      </p:sp>
+      <p:sp>
+        <p:nvSpPr>
+          <p:cNvPr id="3" name="Notes Placeholder 2"/>
+          <p:cNvSpPr>
+            <a:spLocks noGrp="1"/>
+          </p:cNvSpPr>
+          <p:nvPr>
+            <p:ph type="body" idx="1"/>
+          </p:nvPr>
+        </p:nvSpPr>
+        <p:spPr/>
+        <p:txBody>
+          <a:bodyPr/>
+          <a:lstStyle/>
+          <a:p>
+            <a:r>
+              <a:rPr lang="en-US" dirty="0"/>
+              <a:t/>
+            </a:r>
+            <a:endParaRPr lang="en-US" dirty="0"/>
+          </a:p>
+        </p:txBody>
+      </p:sp>
+      <p:sp>
+        <p:nvSpPr>
+          <p:cNvPr id="4" name="Slide Number Placeholder 3"/>
+          <p:cNvSpPr>
+            <a:spLocks noGrp="1"/>
+          </p:cNvSpPr>
+          <p:nvPr>
+            <p:ph type="sldNum" sz="quarter" idx="10"/>
+          </p:nvPr>
+        </p:nvSpPr>
+        <p:spPr/>
+        <p:txBody>
+          <a:bodyPr/>
+          <a:lstStyle/>
+          <a:p>
+            <a:fld id="{F7021451-1387-4CA6-816F-3879F97B5CBC}" type="slidenum">
+              <a:rPr lang="en-US"/>
+              <a:t>10</a:t>
+            </a:fld>
+            <a:endParaRPr lang="en-US"/>
+          </a:p>
+        </p:txBody>
+      </p:sp>
+    </p:spTree>
+    <p:extLst>
+      <p:ext uri="{BB962C8B-B14F-4D97-AF65-F5344CB8AC3E}">
+        <p14:creationId xmlns:p14="http://schemas.microsoft.com/office/powerpoint/2010/main" val="1024086991"/>
+      </p:ext>
+    </p:extLst>
+  </p:cSld>
+  <p:clrMapOvr>
+    <a:masterClrMapping/>
+  </p:clrMapOvr>
+</p:notes>
+</file>
+
 <file path=ppt/notesSlides/notesSlide2.xml><?xml version="1.0" encoding="utf-8"?>
 <p:notes xmlns:a="http://schemas.openxmlformats.org/drawingml/2006/main" xmlns:r="http://schemas.openxmlformats.org/officeDocument/2006/relationships" xmlns:p="http://schemas.openxmlformats.org/presentationml/2006/main">
   <p:cSld>
@@ -685,7 +775,7 @@
           <a:p>
             <a:r>
               <a:rPr lang="en-US" dirty="0"/>
-              <a:t>A ferramenta é chamada por código em toda avaliação, garantindo que o contraste seja sempre calculado. Os LLMs só interpretam e recomendam.</a:t>
+              <a:t>O verificador não é um terceiro agente: é um nó determinístico que usa a ferramenta. O trabalho mantém dois agentes com LLM.</a:t>
             </a:r>
             <a:endParaRPr lang="en-US" dirty="0"/>
           </a:p>
@@ -1037,7 +1127,7 @@
           <a:p>
             <a:r>
               <a:rPr lang="en-US" dirty="0"/>
-              <a:t/>
+              <a:t>Valores calculados com a mesma fórmula da ferramenta do notebook.</a:t>
             </a:r>
             <a:endParaRPr lang="en-US" dirty="0"/>
           </a:p>
@@ -1125,7 +1215,7 @@
           <a:p>
             <a:r>
               <a:rPr lang="en-US" dirty="0"/>
-              <a:t/>
+              <a:t>A correção reforça a colaboração: o resultado do Consultor passa a alimentar outra etapa, que o valida.</a:t>
             </a:r>
             <a:endParaRPr lang="en-US" dirty="0"/>
           </a:p>
@@ -1149,6 +1239,94 @@
             <a:fld id="{F7021451-1387-4CA6-816F-3879F97B5CBC}" type="slidenum">
               <a:rPr lang="en-US"/>
               <a:t>8</a:t>
+            </a:fld>
+            <a:endParaRPr lang="en-US"/>
+          </a:p>
+        </p:txBody>
+      </p:sp>
+    </p:spTree>
+    <p:extLst>
+      <p:ext uri="{BB962C8B-B14F-4D97-AF65-F5344CB8AC3E}">
+        <p14:creationId xmlns:p14="http://schemas.microsoft.com/office/powerpoint/2010/main" val="1024086991"/>
+      </p:ext>
+    </p:extLst>
+  </p:cSld>
+  <p:clrMapOvr>
+    <a:masterClrMapping/>
+  </p:clrMapOvr>
+</p:notes>
+</file>
+
+<file path=ppt/notesSlides/notesSlide9.xml><?xml version="1.0" encoding="utf-8"?>
+<p:notes xmlns:a="http://schemas.openxmlformats.org/drawingml/2006/main" xmlns:r="http://schemas.openxmlformats.org/officeDocument/2006/relationships" xmlns:p="http://schemas.openxmlformats.org/presentationml/2006/main">
+  <p:cSld>
+    <p:spTree>
+      <p:nvGrpSpPr>
+        <p:cNvPr id="1" name=""/>
+        <p:cNvGrpSpPr/>
+        <p:nvPr/>
+      </p:nvGrpSpPr>
+      <p:grpSpPr>
+        <a:xfrm>
+          <a:off x="0" y="0"/>
+          <a:ext cx="0" cy="0"/>
+          <a:chOff x="0" y="0"/>
+          <a:chExt cx="0" cy="0"/>
+        </a:xfrm>
+      </p:grpSpPr>
+      <p:sp>
+        <p:nvSpPr>
+          <p:cNvPr id="2" name="Slide Image Placeholder 1"/>
+          <p:cNvSpPr>
+            <a:spLocks noGrp="1" noRot="1" noChangeAspect="1"/>
+          </p:cNvSpPr>
+          <p:nvPr>
+            <p:ph type="sldImg"/>
+          </p:nvPr>
+        </p:nvSpPr>
+        <p:spPr/>
+      </p:sp>
+      <p:sp>
+        <p:nvSpPr>
+          <p:cNvPr id="3" name="Notes Placeholder 2"/>
+          <p:cNvSpPr>
+            <a:spLocks noGrp="1"/>
+          </p:cNvSpPr>
+          <p:nvPr>
+            <p:ph type="body" idx="1"/>
+          </p:nvPr>
+        </p:nvSpPr>
+        <p:spPr/>
+        <p:txBody>
+          <a:bodyPr/>
+          <a:lstStyle/>
+          <a:p>
+            <a:r>
+              <a:rPr lang="en-US" dirty="0"/>
+              <a:t/>
+            </a:r>
+            <a:endParaRPr lang="en-US" dirty="0"/>
+          </a:p>
+        </p:txBody>
+      </p:sp>
+      <p:sp>
+        <p:nvSpPr>
+          <p:cNvPr id="4" name="Slide Number Placeholder 3"/>
+          <p:cNvSpPr>
+            <a:spLocks noGrp="1"/>
+          </p:cNvSpPr>
+          <p:nvPr>
+            <p:ph type="sldNum" sz="quarter" idx="10"/>
+          </p:nvPr>
+        </p:nvSpPr>
+        <p:spPr/>
+        <p:txBody>
+          <a:bodyPr/>
+          <a:lstStyle/>
+          <a:p>
+            <a:fld id="{F7021451-1387-4CA6-816F-3879F97B5CBC}" type="slidenum">
+              <a:rPr lang="en-US"/>
+              <a:t>9</a:t>
             </a:fld>
             <a:endParaRPr lang="en-US"/>
           </a:p>
@@ -1960,6 +2138,172 @@
 </p:sld>
 </file>
 
+<file path=ppt/slides/slide10.xml><?xml version="1.0" encoding="utf-8"?>
+<p:sld xmlns:a="http://schemas.openxmlformats.org/drawingml/2006/main" xmlns:r="http://schemas.openxmlformats.org/officeDocument/2006/relationships" xmlns:p="http://schemas.openxmlformats.org/presentationml/2006/main">
+  <p:cSld name="Slide 10">
+    <p:bg>
+      <p:bgPr>
+        <a:solidFill>
+          <a:srgbClr val="F2B84B"/>
+        </a:solidFill>
+      </p:bgPr>
+    </p:bg>
+    <p:spTree>
+      <p:nvGrpSpPr>
+        <p:cNvPr id="1" name=""/>
+        <p:cNvGrpSpPr/>
+        <p:nvPr/>
+      </p:nvGrpSpPr>
+      <p:grpSpPr>
+        <a:xfrm>
+          <a:off x="0" y="0"/>
+          <a:ext cx="0" cy="0"/>
+          <a:chOff x="0" y="0"/>
+          <a:chExt cx="0" cy="0"/>
+        </a:xfrm>
+      </p:grpSpPr>
+      <p:sp>
+        <p:nvSpPr>
+          <p:cNvPr id="2" name="Text 0"/>
+          <p:cNvSpPr/>
+          <p:nvPr>
+            <p:ph type="title"/>
+          </p:nvPr>
+        </p:nvSpPr>
+        <p:spPr>
+          <a:xfrm>
+            <a:off x="812800" y="2451100"/>
+            <a:ext cx="10883392" cy="640080"/>
+          </a:xfrm>
+          <a:prstGeom prst="rect">
+            <a:avLst/>
+          </a:prstGeom>
+          <a:noFill/>
+          <a:ln/>
+        </p:spPr>
+        <p:txBody>
+          <a:bodyPr wrap="square" lIns="0" tIns="0" rIns="0" bIns="0" rtlCol="0" anchor="t">
+            <a:normAutofit/>
+          </a:bodyPr>
+          <a:lstStyle/>
+          <a:p>
+            <a:pPr algn="l" indent="0" marL="0">
+              <a:lnSpc>
+                <a:spcPts val="4840"/>
+              </a:lnSpc>
+              <a:buNone/>
+            </a:pPr>
+            <a:r>
+              <a:rPr lang="en-US" sz="4400" b="1" i="0" dirty="0">
+                <a:solidFill>
+                  <a:srgbClr val="0F1B2D"/>
+                </a:solidFill>
+                <a:latin typeface="Helvetica" pitchFamily="34" charset="0"/>
+                <a:ea typeface="Helvetica" pitchFamily="34" charset="-122"/>
+                <a:cs typeface="Helvetica" pitchFamily="34" charset="-120"/>
+              </a:rPr>
+              <a:t>Vídeo de apresentação</a:t>
+            </a:r>
+            <a:endParaRPr lang="en-US" sz="4400" dirty="0"/>
+          </a:p>
+        </p:txBody>
+      </p:sp>
+      <p:sp>
+        <p:nvSpPr>
+          <p:cNvPr id="3" name="Text 1"/>
+          <p:cNvSpPr/>
+          <p:nvPr/>
+        </p:nvSpPr>
+        <p:spPr>
+          <a:xfrm>
+            <a:off x="812800" y="3319779"/>
+            <a:ext cx="10883392" cy="388620"/>
+          </a:xfrm>
+          <a:prstGeom prst="rect">
+            <a:avLst/>
+          </a:prstGeom>
+          <a:noFill/>
+          <a:ln/>
+        </p:spPr>
+        <p:txBody>
+          <a:bodyPr wrap="square" lIns="0" tIns="0" rIns="0" bIns="0" rtlCol="0" anchor="t">
+            <a:normAutofit/>
+          </a:bodyPr>
+          <a:lstStyle/>
+          <a:p>
+            <a:pPr algn="l" indent="0" marL="0">
+              <a:lnSpc>
+                <a:spcPts val="2860"/>
+              </a:lnSpc>
+              <a:buNone/>
+            </a:pPr>
+            <a:r>
+              <a:rPr lang="en-US" sz="2200" dirty="0">
+                <a:solidFill>
+                  <a:srgbClr val="0F1B2D"/>
+                </a:solidFill>
+                <a:latin typeface="Helvetica" pitchFamily="34" charset="0"/>
+                <a:ea typeface="Helvetica" pitchFamily="34" charset="-122"/>
+                <a:cs typeface="Helvetica" pitchFamily="34" charset="-120"/>
+              </a:rPr>
+              <a:t>[colar aqui o link do vídeo]</a:t>
+            </a:r>
+            <a:endParaRPr lang="en-US" sz="2200" dirty="0"/>
+          </a:p>
+        </p:txBody>
+      </p:sp>
+      <p:sp>
+        <p:nvSpPr>
+          <p:cNvPr id="4" name="Text 2"/>
+          <p:cNvSpPr/>
+          <p:nvPr/>
+        </p:nvSpPr>
+        <p:spPr>
+          <a:xfrm>
+            <a:off x="812800" y="3937000"/>
+            <a:ext cx="10883392" cy="292100"/>
+          </a:xfrm>
+          <a:prstGeom prst="rect">
+            <a:avLst/>
+          </a:prstGeom>
+          <a:noFill/>
+          <a:ln/>
+        </p:spPr>
+        <p:txBody>
+          <a:bodyPr wrap="square" lIns="0" tIns="0" rIns="0" bIns="0" rtlCol="0" anchor="t">
+            <a:normAutofit/>
+          </a:bodyPr>
+          <a:lstStyle/>
+          <a:p>
+            <a:pPr algn="l" indent="0" marL="0">
+              <a:lnSpc>
+                <a:spcPts val="2100"/>
+              </a:lnSpc>
+              <a:buNone/>
+            </a:pPr>
+            <a:r>
+              <a:rPr lang="en-US" sz="1500" dirty="0">
+                <a:solidFill>
+                  <a:srgbClr val="0F1B2D"/>
+                </a:solidFill>
+                <a:latin typeface="Helvetica" pitchFamily="34" charset="0"/>
+                <a:ea typeface="Helvetica" pitchFamily="34" charset="-122"/>
+                <a:cs typeface="Helvetica" pitchFamily="34" charset="-120"/>
+              </a:rPr>
+              <a:t>Anderson Fernandes Barbosa · João Pedro Brites</a:t>
+            </a:r>
+            <a:endParaRPr lang="en-US" sz="1500" dirty="0"/>
+          </a:p>
+        </p:txBody>
+      </p:sp>
+    </p:spTree>
+  </p:cSld>
+  <p:clrMapOvr>
+    <a:masterClrMapping/>
+  </p:clrMapOvr>
+</p:sld>
+</file>
+
 <file path=ppt/slides/slide2.xml><?xml version="1.0" encoding="utf-8"?>
 <p:sld xmlns:a="http://schemas.openxmlformats.org/drawingml/2006/main" xmlns:r="http://schemas.openxmlformats.org/officeDocument/2006/relationships" xmlns:p="http://schemas.openxmlformats.org/presentationml/2006/main">
   <p:cSld name="Slide 2">
@@ -2269,7 +2613,7 @@
         <p:spPr>
           <a:xfrm>
             <a:off x="4669367" y="3149600"/>
-            <a:ext cx="2938865" cy="768350"/>
+            <a:ext cx="2938865" cy="1016000"/>
           </a:xfrm>
           <a:prstGeom prst="rect">
             <a:avLst/>
@@ -2298,7 +2642,7 @@
                 <a:ea typeface="Helvetica" pitchFamily="34" charset="-122"/>
                 <a:cs typeface="Helvetica" pitchFamily="34" charset="-120"/>
               </a:rPr>
-              <a:t>Cálculo determinístico da razão de contraste, diagnóstico técnico e recomendações de UX.</a:t>
+              <a:t>Cálculo determinístico do contraste, diagnóstico técnico, recomendações de UX e verificação das cores sugeridas.</a:t>
             </a:r>
             <a:endParaRPr lang="en-US" sz="1500" dirty="0"/>
           </a:p>
@@ -2413,7 +2757,7 @@
                 <a:ea typeface="Helvetica" pitchFamily="34" charset="-122"/>
                 <a:cs typeface="Helvetica" pitchFamily="34" charset="-120"/>
               </a:rPr>
-              <a:t>Relatório com a razão medida, a avaliação AA e AAA para texto normal e grande, e ações práticas.</a:t>
+              <a:t>Relatório com a razão medida, a avaliação AA e AAA para texto normal e grande, e ações práticas com cores verificadas.</a:t>
             </a:r>
             <a:endParaRPr lang="en-US" sz="1500" dirty="0"/>
           </a:p>
@@ -2549,12 +2893,12 @@
         </p:nvSpPr>
         <p:spPr>
           <a:xfrm>
-            <a:off x="812800" y="1876425"/>
-            <a:ext cx="1872192" cy="1385570"/>
+            <a:off x="812800" y="1852930"/>
+            <a:ext cx="1352232" cy="1005840"/>
           </a:xfrm>
           <a:prstGeom prst="roundRect">
             <a:avLst>
-              <a:gd name="adj" fmla="val 7333"/>
+              <a:gd name="adj" fmla="val 10101"/>
             </a:avLst>
           </a:prstGeom>
           <a:solidFill>
@@ -2571,8 +2915,8 @@
         </p:nvSpPr>
         <p:spPr>
           <a:xfrm>
-            <a:off x="1016000" y="2079625"/>
-            <a:ext cx="1516592" cy="284480"/>
+            <a:off x="965200" y="2005330"/>
+            <a:ext cx="1098232" cy="254000"/>
           </a:xfrm>
           <a:prstGeom prst="rect">
             <a:avLst/>
@@ -2588,12 +2932,12 @@
           <a:p>
             <a:pPr algn="l" indent="0" marL="0">
               <a:lnSpc>
-                <a:spcPts val="2040"/>
-              </a:lnSpc>
-              <a:buNone/>
-            </a:pPr>
-            <a:r>
-              <a:rPr lang="en-US" sz="1700" b="1" dirty="0">
+                <a:spcPts val="1800"/>
+              </a:lnSpc>
+              <a:buNone/>
+            </a:pPr>
+            <a:r>
+              <a:rPr lang="en-US" sz="1500" b="1" dirty="0">
                 <a:solidFill>
                   <a:srgbClr val="C9D3E0"/>
                 </a:solidFill>
@@ -2603,7 +2947,7 @@
               </a:rPr>
               <a:t>Entrada</a:t>
             </a:r>
-            <a:endParaRPr lang="en-US" sz="1700" dirty="0"/>
+            <a:endParaRPr lang="en-US" sz="1500" dirty="0"/>
           </a:p>
         </p:txBody>
       </p:sp>
@@ -2615,8 +2959,8 @@
         </p:nvSpPr>
         <p:spPr>
           <a:xfrm>
-            <a:off x="1016000" y="2414905"/>
-            <a:ext cx="1516592" cy="669290"/>
+            <a:off x="965200" y="2310130"/>
+            <a:ext cx="1098232" cy="421640"/>
           </a:xfrm>
           <a:prstGeom prst="rect">
             <a:avLst/>
@@ -2632,12 +2976,12 @@
           <a:p>
             <a:pPr algn="l" indent="0" marL="0">
               <a:lnSpc>
-                <a:spcPts val="1690"/>
-              </a:lnSpc>
-              <a:buNone/>
-            </a:pPr>
-            <a:r>
-              <a:rPr lang="en-US" sz="1300" dirty="0">
+                <a:spcPts val="1560"/>
+              </a:lnSpc>
+              <a:buNone/>
+            </a:pPr>
+            <a:r>
+              <a:rPr lang="en-US" sz="1200" dirty="0">
                 <a:solidFill>
                   <a:srgbClr val="F4F1EA"/>
                 </a:solidFill>
@@ -2645,9 +2989,9 @@
                 <a:ea typeface="Helvetica" pitchFamily="34" charset="-122"/>
                 <a:cs typeface="Helvetica" pitchFamily="34" charset="-120"/>
               </a:rPr>
-              <a:t>Cores do texto e do fundo, mais o componente</a:t>
-            </a:r>
-            <a:endParaRPr lang="en-US" sz="1300" dirty="0"/>
+              <a:t>Cores e componente</a:t>
+            </a:r>
+            <a:endParaRPr lang="en-US" sz="1200" dirty="0"/>
           </a:p>
         </p:txBody>
       </p:sp>
@@ -2659,8 +3003,8 @@
         </p:nvSpPr>
         <p:spPr>
           <a:xfrm>
-            <a:off x="2811992" y="2320289"/>
-            <a:ext cx="426720" cy="523240"/>
+            <a:off x="2241233" y="2160270"/>
+            <a:ext cx="335280" cy="416560"/>
           </a:xfrm>
           <a:prstGeom prst="rect">
             <a:avLst/>
@@ -2676,12 +3020,12 @@
           <a:p>
             <a:pPr algn="l" indent="0" marL="0">
               <a:lnSpc>
-                <a:spcPts val="3920"/>
-              </a:lnSpc>
-              <a:buNone/>
-            </a:pPr>
-            <a:r>
-              <a:rPr lang="en-US" sz="2800" dirty="0">
+                <a:spcPts val="3080"/>
+              </a:lnSpc>
+              <a:buNone/>
+            </a:pPr>
+            <a:r>
+              <a:rPr lang="en-US" sz="2200" dirty="0">
                 <a:solidFill>
                   <a:srgbClr val="F2B84B"/>
                 </a:solidFill>
@@ -2691,7 +3035,7 @@
               </a:rPr>
               <a:t>→</a:t>
             </a:r>
-            <a:endParaRPr lang="en-US" sz="2800" dirty="0"/>
+            <a:endParaRPr lang="en-US" sz="2200" dirty="0"/>
           </a:p>
         </p:txBody>
       </p:sp>
@@ -2703,12 +3047,12 @@
         </p:nvSpPr>
         <p:spPr>
           <a:xfrm>
-            <a:off x="3304117" y="1759586"/>
-            <a:ext cx="2477558" cy="1619250"/>
+            <a:off x="2606358" y="1744345"/>
+            <a:ext cx="2025862" cy="1223010"/>
           </a:xfrm>
           <a:prstGeom prst="roundRect">
             <a:avLst>
-              <a:gd name="adj" fmla="val 5686"/>
+              <a:gd name="adj" fmla="val 7529"/>
             </a:avLst>
           </a:prstGeom>
           <a:solidFill>
@@ -2730,8 +3074,8 @@
         </p:nvSpPr>
         <p:spPr>
           <a:xfrm>
-            <a:off x="3516842" y="1972311"/>
-            <a:ext cx="2113672" cy="284480"/>
+            <a:off x="2768283" y="1906270"/>
+            <a:ext cx="1753072" cy="254000"/>
           </a:xfrm>
           <a:prstGeom prst="rect">
             <a:avLst/>
@@ -2747,12 +3091,12 @@
           <a:p>
             <a:pPr algn="l" indent="0" marL="0">
               <a:lnSpc>
-                <a:spcPts val="2040"/>
-              </a:lnSpc>
-              <a:buNone/>
-            </a:pPr>
-            <a:r>
-              <a:rPr lang="en-US" sz="1700" b="1" dirty="0">
+                <a:spcPts val="1800"/>
+              </a:lnSpc>
+              <a:buNone/>
+            </a:pPr>
+            <a:r>
+              <a:rPr lang="en-US" sz="1500" b="1" dirty="0">
                 <a:solidFill>
                   <a:srgbClr val="F2B84B"/>
                 </a:solidFill>
@@ -2762,7 +3106,7 @@
               </a:rPr>
               <a:t>Agente 1: Auditor</a:t>
             </a:r>
-            <a:endParaRPr lang="en-US" sz="1700" dirty="0"/>
+            <a:endParaRPr lang="en-US" sz="1500" dirty="0"/>
           </a:p>
         </p:txBody>
       </p:sp>
@@ -2774,8 +3118,8 @@
         </p:nvSpPr>
         <p:spPr>
           <a:xfrm>
-            <a:off x="3516842" y="2307589"/>
-            <a:ext cx="2113672" cy="883920"/>
+            <a:off x="2768283" y="2211070"/>
+            <a:ext cx="1753072" cy="619760"/>
           </a:xfrm>
           <a:prstGeom prst="rect">
             <a:avLst/>
@@ -2791,12 +3135,12 @@
           <a:p>
             <a:pPr algn="l" indent="0" marL="0">
               <a:lnSpc>
-                <a:spcPts val="1690"/>
-              </a:lnSpc>
-              <a:buNone/>
-            </a:pPr>
-            <a:r>
-              <a:rPr lang="en-US" sz="1300" dirty="0">
+                <a:spcPts val="1560"/>
+              </a:lnSpc>
+              <a:buNone/>
+            </a:pPr>
+            <a:r>
+              <a:rPr lang="en-US" sz="1200" dirty="0">
                 <a:solidFill>
                   <a:srgbClr val="F4F1EA"/>
                 </a:solidFill>
@@ -2804,9 +3148,9 @@
                 <a:ea typeface="Helvetica" pitchFamily="34" charset="-122"/>
                 <a:cs typeface="Helvetica" pitchFamily="34" charset="-120"/>
               </a:rPr>
-              <a:t>Aciona a ferramenta avaliar_contraste (@tool) e interpreta o resultado sem recalcular</a:t>
-            </a:r>
-            <a:endParaRPr lang="en-US" sz="1300" dirty="0"/>
+              <a:t>Aciona a @tool avaliar_contraste e interpreta o resultado</a:t>
+            </a:r>
+            <a:endParaRPr lang="en-US" sz="1200" dirty="0"/>
           </a:p>
         </p:txBody>
       </p:sp>
@@ -2818,8 +3162,8 @@
         </p:nvSpPr>
         <p:spPr>
           <a:xfrm>
-            <a:off x="5918200" y="2320289"/>
-            <a:ext cx="426720" cy="523240"/>
+            <a:off x="4717944" y="2160270"/>
+            <a:ext cx="335280" cy="416560"/>
           </a:xfrm>
           <a:prstGeom prst="rect">
             <a:avLst/>
@@ -2835,12 +3179,12 @@
           <a:p>
             <a:pPr algn="l" indent="0" marL="0">
               <a:lnSpc>
-                <a:spcPts val="3920"/>
-              </a:lnSpc>
-              <a:buNone/>
-            </a:pPr>
-            <a:r>
-              <a:rPr lang="en-US" sz="2800" dirty="0">
+                <a:spcPts val="3080"/>
+              </a:lnSpc>
+              <a:buNone/>
+            </a:pPr>
+            <a:r>
+              <a:rPr lang="en-US" sz="2200" dirty="0">
                 <a:solidFill>
                   <a:srgbClr val="F2B84B"/>
                 </a:solidFill>
@@ -2850,7 +3194,7 @@
               </a:rPr>
               <a:t>→</a:t>
             </a:r>
-            <a:endParaRPr lang="en-US" sz="2800" dirty="0"/>
+            <a:endParaRPr lang="en-US" sz="2200" dirty="0"/>
           </a:p>
         </p:txBody>
       </p:sp>
@@ -2862,12 +3206,12 @@
         </p:nvSpPr>
         <p:spPr>
           <a:xfrm>
-            <a:off x="6410325" y="1630045"/>
-            <a:ext cx="2477558" cy="1878330"/>
+            <a:off x="5083069" y="1630045"/>
+            <a:ext cx="2025862" cy="1451610"/>
           </a:xfrm>
           <a:prstGeom prst="roundRect">
             <a:avLst>
-              <a:gd name="adj" fmla="val 4902"/>
+              <a:gd name="adj" fmla="val 6343"/>
             </a:avLst>
           </a:prstGeom>
           <a:solidFill>
@@ -2889,8 +3233,8 @@
         </p:nvSpPr>
         <p:spPr>
           <a:xfrm>
-            <a:off x="6623050" y="1842770"/>
-            <a:ext cx="2113672" cy="543560"/>
+            <a:off x="5244994" y="1791970"/>
+            <a:ext cx="1753072" cy="482600"/>
           </a:xfrm>
           <a:prstGeom prst="rect">
             <a:avLst/>
@@ -2906,12 +3250,12 @@
           <a:p>
             <a:pPr algn="l" indent="0" marL="0">
               <a:lnSpc>
-                <a:spcPts val="2040"/>
-              </a:lnSpc>
-              <a:buNone/>
-            </a:pPr>
-            <a:r>
-              <a:rPr lang="en-US" sz="1700" b="1" dirty="0">
+                <a:spcPts val="1800"/>
+              </a:lnSpc>
+              <a:buNone/>
+            </a:pPr>
+            <a:r>
+              <a:rPr lang="en-US" sz="1500" b="1" dirty="0">
                 <a:solidFill>
                   <a:srgbClr val="5BA8E6"/>
                 </a:solidFill>
@@ -2921,7 +3265,7 @@
               </a:rPr>
               <a:t>Agente 2: Consultor UX</a:t>
             </a:r>
-            <a:endParaRPr lang="en-US" sz="1700" dirty="0"/>
+            <a:endParaRPr lang="en-US" sz="1500" dirty="0"/>
           </a:p>
         </p:txBody>
       </p:sp>
@@ -2933,8 +3277,8 @@
         </p:nvSpPr>
         <p:spPr>
           <a:xfrm>
-            <a:off x="6623050" y="2437130"/>
-            <a:ext cx="2113672" cy="883920"/>
+            <a:off x="5244994" y="2325370"/>
+            <a:ext cx="1753072" cy="619760"/>
           </a:xfrm>
           <a:prstGeom prst="rect">
             <a:avLst/>
@@ -2950,12 +3294,12 @@
           <a:p>
             <a:pPr algn="l" indent="0" marL="0">
               <a:lnSpc>
-                <a:spcPts val="1690"/>
-              </a:lnSpc>
-              <a:buNone/>
-            </a:pPr>
-            <a:r>
-              <a:rPr lang="en-US" sz="1300" dirty="0">
+                <a:spcPts val="1560"/>
+              </a:lnSpc>
+              <a:buNone/>
+            </a:pPr>
+            <a:r>
+              <a:rPr lang="en-US" sz="1200" dirty="0">
                 <a:solidFill>
                   <a:srgbClr val="F4F1EA"/>
                 </a:solidFill>
@@ -2963,9 +3307,9 @@
                 <a:ea typeface="Helvetica" pitchFamily="34" charset="-122"/>
                 <a:cs typeface="Helvetica" pitchFamily="34" charset="-120"/>
               </a:rPr>
-              <a:t>Recebe medição e diagnóstico, explica o impacto e propõe duas ações práticas</a:t>
-            </a:r>
-            <a:endParaRPr lang="en-US" sz="1300" dirty="0"/>
+              <a:t>Explica o impacto e sugere novas cores em formato padronizado</a:t>
+            </a:r>
+            <a:endParaRPr lang="en-US" sz="1200" dirty="0"/>
           </a:p>
         </p:txBody>
       </p:sp>
@@ -2977,8 +3321,8 @@
         </p:nvSpPr>
         <p:spPr>
           <a:xfrm>
-            <a:off x="9024408" y="2320289"/>
-            <a:ext cx="426720" cy="523240"/>
+            <a:off x="7194655" y="2160270"/>
+            <a:ext cx="335280" cy="416560"/>
           </a:xfrm>
           <a:prstGeom prst="rect">
             <a:avLst/>
@@ -2994,12 +3338,12 @@
           <a:p>
             <a:pPr algn="l" indent="0" marL="0">
               <a:lnSpc>
-                <a:spcPts val="3920"/>
-              </a:lnSpc>
-              <a:buNone/>
-            </a:pPr>
-            <a:r>
-              <a:rPr lang="en-US" sz="2800" dirty="0">
+                <a:spcPts val="3080"/>
+              </a:lnSpc>
+              <a:buNone/>
+            </a:pPr>
+            <a:r>
+              <a:rPr lang="en-US" sz="2200" dirty="0">
                 <a:solidFill>
                   <a:srgbClr val="F2B84B"/>
                 </a:solidFill>
@@ -3009,7 +3353,7 @@
               </a:rPr>
               <a:t>→</a:t>
             </a:r>
-            <a:endParaRPr lang="en-US" sz="2800" dirty="0"/>
+            <a:endParaRPr lang="en-US" sz="2200" dirty="0"/>
           </a:p>
         </p:txBody>
       </p:sp>
@@ -3021,12 +3365,171 @@
         </p:nvSpPr>
         <p:spPr>
           <a:xfrm>
-            <a:off x="9507008" y="1876425"/>
-            <a:ext cx="1872192" cy="1385570"/>
+            <a:off x="7559780" y="1744345"/>
+            <a:ext cx="2025862" cy="1223010"/>
           </a:xfrm>
           <a:prstGeom prst="roundRect">
             <a:avLst>
-              <a:gd name="adj" fmla="val 7333"/>
+              <a:gd name="adj" fmla="val 7529"/>
+            </a:avLst>
+          </a:prstGeom>
+          <a:solidFill>
+            <a:srgbClr val="1B2A41"/>
+          </a:solidFill>
+          <a:ln w="19050">
+            <a:solidFill>
+              <a:srgbClr val="F4F1EA"/>
+            </a:solidFill>
+            <a:prstDash val="dash"/>
+          </a:ln>
+        </p:spPr>
+      </p:sp>
+      <p:sp>
+        <p:nvSpPr>
+          <p:cNvPr id="16" name="Text 14"/>
+          <p:cNvSpPr/>
+          <p:nvPr/>
+        </p:nvSpPr>
+        <p:spPr>
+          <a:xfrm>
+            <a:off x="7721705" y="1906270"/>
+            <a:ext cx="1753072" cy="254000"/>
+          </a:xfrm>
+          <a:prstGeom prst="rect">
+            <a:avLst/>
+          </a:prstGeom>
+          <a:noFill/>
+          <a:ln/>
+        </p:spPr>
+        <p:txBody>
+          <a:bodyPr wrap="square" lIns="0" tIns="0" rIns="0" bIns="0" rtlCol="0" anchor="t">
+            <a:normAutofit/>
+          </a:bodyPr>
+          <a:lstStyle/>
+          <a:p>
+            <a:pPr algn="l" indent="0" marL="0">
+              <a:lnSpc>
+                <a:spcPts val="1800"/>
+              </a:lnSpc>
+              <a:buNone/>
+            </a:pPr>
+            <a:r>
+              <a:rPr lang="en-US" sz="1500" b="1" dirty="0">
+                <a:solidFill>
+                  <a:srgbClr val="F4F1EA"/>
+                </a:solidFill>
+                <a:latin typeface="Helvetica" pitchFamily="34" charset="0"/>
+                <a:ea typeface="Helvetica" pitchFamily="34" charset="-122"/>
+                <a:cs typeface="Helvetica" pitchFamily="34" charset="-120"/>
+              </a:rPr>
+              <a:t>Nó Verificador</a:t>
+            </a:r>
+            <a:endParaRPr lang="en-US" sz="1500" dirty="0"/>
+          </a:p>
+        </p:txBody>
+      </p:sp>
+      <p:sp>
+        <p:nvSpPr>
+          <p:cNvPr id="17" name="Text 15"/>
+          <p:cNvSpPr/>
+          <p:nvPr/>
+        </p:nvSpPr>
+        <p:spPr>
+          <a:xfrm>
+            <a:off x="7721705" y="2211070"/>
+            <a:ext cx="1753072" cy="619760"/>
+          </a:xfrm>
+          <a:prstGeom prst="rect">
+            <a:avLst/>
+          </a:prstGeom>
+          <a:noFill/>
+          <a:ln/>
+        </p:spPr>
+        <p:txBody>
+          <a:bodyPr wrap="square" lIns="0" tIns="0" rIns="0" bIns="0" rtlCol="0" anchor="t">
+            <a:normAutofit/>
+          </a:bodyPr>
+          <a:lstStyle/>
+          <a:p>
+            <a:pPr algn="l" indent="0" marL="0">
+              <a:lnSpc>
+                <a:spcPts val="1560"/>
+              </a:lnSpc>
+              <a:buNone/>
+            </a:pPr>
+            <a:r>
+              <a:rPr lang="en-US" sz="1200" dirty="0">
+                <a:solidFill>
+                  <a:srgbClr val="F4F1EA"/>
+                </a:solidFill>
+                <a:latin typeface="Helvetica" pitchFamily="34" charset="0"/>
+                <a:ea typeface="Helvetica" pitchFamily="34" charset="-122"/>
+                <a:cs typeface="Helvetica" pitchFamily="34" charset="-120"/>
+              </a:rPr>
+              <a:t>Recalcula cada cor sugerida com a mesma @tool, sem LLM</a:t>
+            </a:r>
+            <a:endParaRPr lang="en-US" sz="1200" dirty="0"/>
+          </a:p>
+        </p:txBody>
+      </p:sp>
+      <p:sp>
+        <p:nvSpPr>
+          <p:cNvPr id="18" name="Text 16"/>
+          <p:cNvSpPr/>
+          <p:nvPr/>
+        </p:nvSpPr>
+        <p:spPr>
+          <a:xfrm>
+            <a:off x="9671368" y="2160270"/>
+            <a:ext cx="335280" cy="416560"/>
+          </a:xfrm>
+          <a:prstGeom prst="rect">
+            <a:avLst/>
+          </a:prstGeom>
+          <a:noFill/>
+          <a:ln/>
+        </p:spPr>
+        <p:txBody>
+          <a:bodyPr wrap="square" lIns="0" tIns="0" rIns="0" bIns="0" rtlCol="0" anchor="t">
+            <a:normAutofit/>
+          </a:bodyPr>
+          <a:lstStyle/>
+          <a:p>
+            <a:pPr algn="l" indent="0" marL="0">
+              <a:lnSpc>
+                <a:spcPts val="3080"/>
+              </a:lnSpc>
+              <a:buNone/>
+            </a:pPr>
+            <a:r>
+              <a:rPr lang="en-US" sz="2200" dirty="0">
+                <a:solidFill>
+                  <a:srgbClr val="F2B84B"/>
+                </a:solidFill>
+                <a:latin typeface="Helvetica" pitchFamily="34" charset="0"/>
+                <a:ea typeface="Helvetica" pitchFamily="34" charset="-122"/>
+                <a:cs typeface="Helvetica" pitchFamily="34" charset="-120"/>
+              </a:rPr>
+              <a:t>→</a:t>
+            </a:r>
+            <a:endParaRPr lang="en-US" sz="2200" dirty="0"/>
+          </a:p>
+        </p:txBody>
+      </p:sp>
+      <p:sp>
+        <p:nvSpPr>
+          <p:cNvPr id="19" name="Shape 17"/>
+          <p:cNvSpPr/>
+          <p:nvPr/>
+        </p:nvSpPr>
+        <p:spPr>
+          <a:xfrm>
+            <a:off x="10026968" y="1852930"/>
+            <a:ext cx="1352232" cy="1005840"/>
+          </a:xfrm>
+          <a:prstGeom prst="roundRect">
+            <a:avLst>
+              <a:gd name="adj" fmla="val 10101"/>
             </a:avLst>
           </a:prstGeom>
           <a:solidFill>
@@ -3037,14 +3540,14 @@
       </p:sp>
       <p:sp>
         <p:nvSpPr>
-          <p:cNvPr id="16" name="Text 14"/>
+          <p:cNvPr id="20" name="Text 18"/>
           <p:cNvSpPr/>
           <p:nvPr/>
         </p:nvSpPr>
         <p:spPr>
           <a:xfrm>
-            <a:off x="9710208" y="2079625"/>
-            <a:ext cx="1516592" cy="284480"/>
+            <a:off x="10179368" y="2005330"/>
+            <a:ext cx="1098232" cy="254000"/>
           </a:xfrm>
           <a:prstGeom prst="rect">
             <a:avLst/>
@@ -3060,12 +3563,12 @@
           <a:p>
             <a:pPr algn="l" indent="0" marL="0">
               <a:lnSpc>
-                <a:spcPts val="2040"/>
-              </a:lnSpc>
-              <a:buNone/>
-            </a:pPr>
-            <a:r>
-              <a:rPr lang="en-US" sz="1700" b="1" dirty="0">
+                <a:spcPts val="1800"/>
+              </a:lnSpc>
+              <a:buNone/>
+            </a:pPr>
+            <a:r>
+              <a:rPr lang="en-US" sz="1500" b="1" dirty="0">
                 <a:solidFill>
                   <a:srgbClr val="C9D3E0"/>
                 </a:solidFill>
@@ -3075,20 +3578,20 @@
               </a:rPr>
               <a:t>Relatório</a:t>
             </a:r>
-            <a:endParaRPr lang="en-US" sz="1700" dirty="0"/>
-          </a:p>
-        </p:txBody>
-      </p:sp>
-      <p:sp>
-        <p:nvSpPr>
-          <p:cNvPr id="17" name="Text 15"/>
+            <a:endParaRPr lang="en-US" sz="1500" dirty="0"/>
+          </a:p>
+        </p:txBody>
+      </p:sp>
+      <p:sp>
+        <p:nvSpPr>
+          <p:cNvPr id="21" name="Text 19"/>
           <p:cNvSpPr/>
           <p:nvPr/>
         </p:nvSpPr>
         <p:spPr>
           <a:xfrm>
-            <a:off x="9710208" y="2414905"/>
-            <a:ext cx="1516592" cy="669290"/>
+            <a:off x="10179368" y="2310130"/>
+            <a:ext cx="1098232" cy="421640"/>
           </a:xfrm>
           <a:prstGeom prst="rect">
             <a:avLst/>
@@ -3104,12 +3607,12 @@
           <a:p>
             <a:pPr algn="l" indent="0" marL="0">
               <a:lnSpc>
-                <a:spcPts val="1690"/>
-              </a:lnSpc>
-              <a:buNone/>
-            </a:pPr>
-            <a:r>
-              <a:rPr lang="en-US" sz="1300" dirty="0">
+                <a:spcPts val="1560"/>
+              </a:lnSpc>
+              <a:buNone/>
+            </a:pPr>
+            <a:r>
+              <a:rPr lang="en-US" sz="1200" dirty="0">
                 <a:solidFill>
                   <a:srgbClr val="F4F1EA"/>
                 </a:solidFill>
@@ -3117,21 +3620,21 @@
                 <a:ea typeface="Helvetica" pitchFamily="34" charset="-122"/>
                 <a:cs typeface="Helvetica" pitchFamily="34" charset="-120"/>
               </a:rPr>
-              <a:t>Medição, diagnóstico e recomendações</a:t>
-            </a:r>
-            <a:endParaRPr lang="en-US" sz="1300" dirty="0"/>
-          </a:p>
-        </p:txBody>
-      </p:sp>
-      <p:sp>
-        <p:nvSpPr>
-          <p:cNvPr id="18" name="Shape 16"/>
+              <a:t>Medições verificadas</a:t>
+            </a:r>
+            <a:endParaRPr lang="en-US" sz="1200" dirty="0"/>
+          </a:p>
+        </p:txBody>
+      </p:sp>
+      <p:sp>
+        <p:nvSpPr>
+          <p:cNvPr id="22" name="Shape 20"/>
           <p:cNvSpPr/>
           <p:nvPr/>
         </p:nvSpPr>
         <p:spPr>
           <a:xfrm>
-            <a:off x="812800" y="3822700"/>
+            <a:off x="812800" y="3395980"/>
             <a:ext cx="10566400" cy="1169670"/>
           </a:xfrm>
           <a:prstGeom prst="roundRect">
@@ -3147,13 +3650,13 @@
       </p:sp>
       <p:sp>
         <p:nvSpPr>
-          <p:cNvPr id="19" name="Text 17"/>
+          <p:cNvPr id="23" name="Text 21"/>
           <p:cNvSpPr/>
           <p:nvPr/>
         </p:nvSpPr>
         <p:spPr>
           <a:xfrm>
-            <a:off x="1016000" y="4025900"/>
+            <a:off x="1016000" y="3599180"/>
             <a:ext cx="10464800" cy="254000"/>
           </a:xfrm>
           <a:prstGeom prst="rect">
@@ -3191,13 +3694,13 @@
       </p:sp>
       <p:sp>
         <p:nvSpPr>
-          <p:cNvPr id="20" name="Text 18"/>
+          <p:cNvPr id="24" name="Text 22"/>
           <p:cNvSpPr/>
           <p:nvPr/>
         </p:nvSpPr>
         <p:spPr>
           <a:xfrm>
-            <a:off x="1016000" y="4343400"/>
+            <a:off x="1016000" y="3916680"/>
             <a:ext cx="10464800" cy="471170"/>
           </a:xfrm>
           <a:prstGeom prst="rect">
@@ -3227,7 +3730,7 @@
                 <a:ea typeface="Helvetica" pitchFamily="34" charset="-122"/>
                 <a:cs typeface="Helvetica" pitchFamily="34" charset="-120"/>
               </a:rPr>
-              <a:t>Grafo: START → auditor → consultor_ux → END. Os agentes se comunicam por um estado compartilhado (TypedDict): resultado_ferramenta → analise_auditor → recomendacao_consultor.</a:t>
+              <a:t>Grafo: START → auditor → consultor_ux → verificador → END. A comunicação é feita pelo estado compartilhado (TypedDict): resultado_ferramenta → analise_auditor → recomendacao_consultor → verificacao_sugestoes.</a:t>
             </a:r>
             <a:endParaRPr lang="en-US" sz="1300" dirty="0"/>
           </a:p>
@@ -4132,11 +4635,11 @@
         <p:spPr>
           <a:xfrm>
             <a:off x="819150" y="1576071"/>
-            <a:ext cx="5981700" cy="3901440"/>
+            <a:ext cx="5981700" cy="4013200"/>
           </a:xfrm>
           <a:prstGeom prst="roundRect">
             <a:avLst>
-              <a:gd name="adj" fmla="val 2441"/>
+              <a:gd name="adj" fmla="val 2373"/>
             </a:avLst>
           </a:prstGeom>
           <a:solidFill>
@@ -4150,7 +4653,7 @@
           </a:ln>
         </p:spPr>
         <p:txBody>
-          <a:bodyPr wrap="square" lIns="232452" tIns="207052" rIns="68622" bIns="207052" rtlCol="0" anchor="t">
+          <a:bodyPr wrap="square" lIns="232452" tIns="207052" rIns="68622" bIns="181652" rtlCol="0" anchor="t">
             <a:normAutofit/>
           </a:bodyPr>
           <a:lstStyle/>
@@ -4221,7 +4724,7 @@
                 <a:ea typeface="Courier New" pitchFamily="49" charset="-122"/>
                 <a:cs typeface="Courier New" pitchFamily="49" charset="-120"/>
               </a:rPr>
-              <a:t>    resposta = llm.invoke([SystemMessage(...),</a:t>
+              <a:t>    resposta = llm.invoke([...])</a:t>
             </a:r>
             <a:endParaRPr lang="en-US" sz="1200" dirty="0"/>
           </a:p>
@@ -4241,39 +4744,39 @@
                 <a:ea typeface="Courier New" pitchFamily="49" charset="-122"/>
                 <a:cs typeface="Courier New" pitchFamily="49" charset="-120"/>
               </a:rPr>
-              <a:t>                            HumanMessage(...)])</a:t>
-            </a:r>
-            <a:endParaRPr lang="en-US" sz="1200" dirty="0"/>
-          </a:p>
-          <a:p>
-            <a:pPr algn="l" indent="0" marL="0">
-              <a:lnSpc>
-                <a:spcPts val="1860"/>
-              </a:lnSpc>
-              <a:buNone/>
-            </a:pPr>
+              <a:t>    return {</a:t>
+            </a:r>
             <a:r>
               <a:rPr lang="en-US" sz="1200" dirty="0">
                 <a:solidFill>
-                  <a:srgbClr val="F4F1EA"/>
+                  <a:srgbClr val="5BA8E6"/>
                 </a:solidFill>
                 <a:latin typeface="Courier New" pitchFamily="49" charset="0"/>
                 <a:ea typeface="Courier New" pitchFamily="49" charset="-122"/>
                 <a:cs typeface="Courier New" pitchFamily="49" charset="-120"/>
               </a:rPr>
-              <a:t>    return {</a:t>
+              <a:t>"resultado_ferramenta"</a:t>
             </a:r>
             <a:r>
               <a:rPr lang="en-US" sz="1200" dirty="0">
                 <a:solidFill>
-                  <a:srgbClr val="5BA8E6"/>
+                  <a:srgbClr val="F4F1EA"/>
                 </a:solidFill>
                 <a:latin typeface="Courier New" pitchFamily="49" charset="0"/>
                 <a:ea typeface="Courier New" pitchFamily="49" charset="-122"/>
                 <a:cs typeface="Courier New" pitchFamily="49" charset="-120"/>
               </a:rPr>
-              <a:t>"resultado_ferramenta"</a:t>
-            </a:r>
+              <a:t>: resultado,</a:t>
+            </a:r>
+            <a:endParaRPr lang="en-US" sz="1200" dirty="0"/>
+          </a:p>
+          <a:p>
+            <a:pPr algn="l" indent="0" marL="0">
+              <a:lnSpc>
+                <a:spcPts val="1860"/>
+              </a:lnSpc>
+              <a:buNone/>
+            </a:pPr>
             <a:r>
               <a:rPr lang="en-US" sz="1200" dirty="0">
                 <a:solidFill>
@@ -4283,39 +4786,48 @@
                 <a:ea typeface="Courier New" pitchFamily="49" charset="-122"/>
                 <a:cs typeface="Courier New" pitchFamily="49" charset="-120"/>
               </a:rPr>
-              <a:t>: resultado,</a:t>
-            </a:r>
-            <a:endParaRPr lang="en-US" sz="1200" dirty="0"/>
-          </a:p>
-          <a:p>
-            <a:pPr algn="l" indent="0" marL="0">
-              <a:lnSpc>
-                <a:spcPts val="1860"/>
-              </a:lnSpc>
-              <a:buNone/>
-            </a:pPr>
+              <a:t>        </a:t>
+            </a:r>
             <a:r>
               <a:rPr lang="en-US" sz="1200" dirty="0">
                 <a:solidFill>
-                  <a:srgbClr val="F4F1EA"/>
+                  <a:srgbClr val="5BA8E6"/>
                 </a:solidFill>
                 <a:latin typeface="Courier New" pitchFamily="49" charset="0"/>
                 <a:ea typeface="Courier New" pitchFamily="49" charset="-122"/>
                 <a:cs typeface="Courier New" pitchFamily="49" charset="-120"/>
               </a:rPr>
-              <a:t>        </a:t>
+              <a:t>"analise_auditor"</a:t>
             </a:r>
             <a:r>
               <a:rPr lang="en-US" sz="1200" dirty="0">
                 <a:solidFill>
-                  <a:srgbClr val="5BA8E6"/>
+                  <a:srgbClr val="F4F1EA"/>
                 </a:solidFill>
                 <a:latin typeface="Courier New" pitchFamily="49" charset="0"/>
                 <a:ea typeface="Courier New" pitchFamily="49" charset="-122"/>
                 <a:cs typeface="Courier New" pitchFamily="49" charset="-120"/>
               </a:rPr>
-              <a:t>"analise_auditor"</a:t>
-            </a:r>
+              <a:t>: resposta.content}</a:t>
+            </a:r>
+            <a:endParaRPr lang="en-US" sz="1200" dirty="0"/>
+          </a:p>
+          <a:p>
+            <a:pPr algn="l" indent="0" marL="0">
+              <a:lnSpc>
+                <a:spcPts val="1860"/>
+              </a:lnSpc>
+              <a:buNone/>
+            </a:pPr>
+            <a:endParaRPr lang="en-US" sz="1200" dirty="0"/>
+          </a:p>
+          <a:p>
+            <a:pPr algn="l" indent="0" marL="0">
+              <a:lnSpc>
+                <a:spcPts val="1860"/>
+              </a:lnSpc>
+              <a:buNone/>
+            </a:pPr>
             <a:r>
               <a:rPr lang="en-US" sz="1200" dirty="0">
                 <a:solidFill>
@@ -4325,17 +4837,8 @@
                 <a:ea typeface="Courier New" pitchFamily="49" charset="-122"/>
                 <a:cs typeface="Courier New" pitchFamily="49" charset="-120"/>
               </a:rPr>
-              <a:t>: resposta.content}</a:t>
-            </a:r>
-            <a:endParaRPr lang="en-US" sz="1200" dirty="0"/>
-          </a:p>
-          <a:p>
-            <a:pPr algn="l" indent="0" marL="0">
-              <a:lnSpc>
-                <a:spcPts val="1860"/>
-              </a:lnSpc>
-              <a:buNone/>
-            </a:pPr>
+              <a:t>grafo = StateGraph(Estado)</a:t>
+            </a:r>
             <a:endParaRPr lang="en-US" sz="1200" dirty="0"/>
           </a:p>
           <a:p>
@@ -4354,39 +4857,39 @@
                 <a:ea typeface="Courier New" pitchFamily="49" charset="-122"/>
                 <a:cs typeface="Courier New" pitchFamily="49" charset="-120"/>
               </a:rPr>
-              <a:t>grafo = StateGraph(Estado)</a:t>
-            </a:r>
-            <a:endParaRPr lang="en-US" sz="1200" dirty="0"/>
-          </a:p>
-          <a:p>
-            <a:pPr algn="l" indent="0" marL="0">
-              <a:lnSpc>
-                <a:spcPts val="1860"/>
-              </a:lnSpc>
-              <a:buNone/>
-            </a:pPr>
+              <a:t>grafo.add_node(</a:t>
+            </a:r>
             <a:r>
               <a:rPr lang="en-US" sz="1200" dirty="0">
                 <a:solidFill>
-                  <a:srgbClr val="F4F1EA"/>
+                  <a:srgbClr val="5BA8E6"/>
                 </a:solidFill>
                 <a:latin typeface="Courier New" pitchFamily="49" charset="0"/>
                 <a:ea typeface="Courier New" pitchFamily="49" charset="-122"/>
                 <a:cs typeface="Courier New" pitchFamily="49" charset="-120"/>
               </a:rPr>
-              <a:t>grafo.add_node(</a:t>
+              <a:t>"auditor"</a:t>
             </a:r>
             <a:r>
               <a:rPr lang="en-US" sz="1200" dirty="0">
                 <a:solidFill>
-                  <a:srgbClr val="5BA8E6"/>
+                  <a:srgbClr val="F4F1EA"/>
                 </a:solidFill>
                 <a:latin typeface="Courier New" pitchFamily="49" charset="0"/>
                 <a:ea typeface="Courier New" pitchFamily="49" charset="-122"/>
                 <a:cs typeface="Courier New" pitchFamily="49" charset="-120"/>
               </a:rPr>
-              <a:t>"auditor"</a:t>
-            </a:r>
+              <a:t>, agente_auditor)</a:t>
+            </a:r>
+            <a:endParaRPr lang="en-US" sz="1200" dirty="0"/>
+          </a:p>
+          <a:p>
+            <a:pPr algn="l" indent="0" marL="0">
+              <a:lnSpc>
+                <a:spcPts val="1860"/>
+              </a:lnSpc>
+              <a:buNone/>
+            </a:pPr>
             <a:r>
               <a:rPr lang="en-US" sz="1200" dirty="0">
                 <a:solidFill>
@@ -4396,39 +4899,39 @@
                 <a:ea typeface="Courier New" pitchFamily="49" charset="-122"/>
                 <a:cs typeface="Courier New" pitchFamily="49" charset="-120"/>
               </a:rPr>
-              <a:t>, agente_auditor)</a:t>
-            </a:r>
-            <a:endParaRPr lang="en-US" sz="1200" dirty="0"/>
-          </a:p>
-          <a:p>
-            <a:pPr algn="l" indent="0" marL="0">
-              <a:lnSpc>
-                <a:spcPts val="1860"/>
-              </a:lnSpc>
-              <a:buNone/>
-            </a:pPr>
+              <a:t>grafo.add_node(</a:t>
+            </a:r>
             <a:r>
               <a:rPr lang="en-US" sz="1200" dirty="0">
                 <a:solidFill>
-                  <a:srgbClr val="F4F1EA"/>
+                  <a:srgbClr val="5BA8E6"/>
                 </a:solidFill>
                 <a:latin typeface="Courier New" pitchFamily="49" charset="0"/>
                 <a:ea typeface="Courier New" pitchFamily="49" charset="-122"/>
                 <a:cs typeface="Courier New" pitchFamily="49" charset="-120"/>
               </a:rPr>
-              <a:t>grafo.add_node(</a:t>
+              <a:t>"consultor_ux"</a:t>
             </a:r>
             <a:r>
               <a:rPr lang="en-US" sz="1200" dirty="0">
                 <a:solidFill>
-                  <a:srgbClr val="5BA8E6"/>
+                  <a:srgbClr val="F4F1EA"/>
                 </a:solidFill>
                 <a:latin typeface="Courier New" pitchFamily="49" charset="0"/>
                 <a:ea typeface="Courier New" pitchFamily="49" charset="-122"/>
                 <a:cs typeface="Courier New" pitchFamily="49" charset="-120"/>
               </a:rPr>
-              <a:t>"consultor_ux"</a:t>
-            </a:r>
+              <a:t>, agente_consultor)</a:t>
+            </a:r>
+            <a:endParaRPr lang="en-US" sz="1200" dirty="0"/>
+          </a:p>
+          <a:p>
+            <a:pPr algn="l" indent="0" marL="0">
+              <a:lnSpc>
+                <a:spcPts val="1860"/>
+              </a:lnSpc>
+              <a:buNone/>
+            </a:pPr>
             <a:r>
               <a:rPr lang="en-US" sz="1200" dirty="0">
                 <a:solidFill>
@@ -4438,39 +4941,39 @@
                 <a:ea typeface="Courier New" pitchFamily="49" charset="-122"/>
                 <a:cs typeface="Courier New" pitchFamily="49" charset="-120"/>
               </a:rPr>
-              <a:t>, agente_consultor)</a:t>
-            </a:r>
-            <a:endParaRPr lang="en-US" sz="1200" dirty="0"/>
-          </a:p>
-          <a:p>
-            <a:pPr algn="l" indent="0" marL="0">
-              <a:lnSpc>
-                <a:spcPts val="1860"/>
-              </a:lnSpc>
-              <a:buNone/>
-            </a:pPr>
+              <a:t>grafo.add_node(</a:t>
+            </a:r>
             <a:r>
               <a:rPr lang="en-US" sz="1200" dirty="0">
                 <a:solidFill>
-                  <a:srgbClr val="F4F1EA"/>
+                  <a:srgbClr val="5BA8E6"/>
                 </a:solidFill>
                 <a:latin typeface="Courier New" pitchFamily="49" charset="0"/>
                 <a:ea typeface="Courier New" pitchFamily="49" charset="-122"/>
                 <a:cs typeface="Courier New" pitchFamily="49" charset="-120"/>
               </a:rPr>
-              <a:t>grafo.add_edge(START, </a:t>
+              <a:t>"verificador"</a:t>
             </a:r>
             <a:r>
               <a:rPr lang="en-US" sz="1200" dirty="0">
                 <a:solidFill>
-                  <a:srgbClr val="5BA8E6"/>
+                  <a:srgbClr val="F4F1EA"/>
                 </a:solidFill>
                 <a:latin typeface="Courier New" pitchFamily="49" charset="0"/>
                 <a:ea typeface="Courier New" pitchFamily="49" charset="-122"/>
                 <a:cs typeface="Courier New" pitchFamily="49" charset="-120"/>
               </a:rPr>
-              <a:t>"auditor"</a:t>
-            </a:r>
+              <a:t>, no_verificador)</a:t>
+            </a:r>
+            <a:endParaRPr lang="en-US" sz="1200" dirty="0"/>
+          </a:p>
+          <a:p>
+            <a:pPr algn="l" indent="0" marL="0">
+              <a:lnSpc>
+                <a:spcPts val="1860"/>
+              </a:lnSpc>
+              <a:buNone/>
+            </a:pPr>
             <a:r>
               <a:rPr lang="en-US" sz="1200" dirty="0">
                 <a:solidFill>
@@ -4480,39 +4983,39 @@
                 <a:ea typeface="Courier New" pitchFamily="49" charset="-122"/>
                 <a:cs typeface="Courier New" pitchFamily="49" charset="-120"/>
               </a:rPr>
-              <a:t>)</a:t>
-            </a:r>
-            <a:endParaRPr lang="en-US" sz="1200" dirty="0"/>
-          </a:p>
-          <a:p>
-            <a:pPr algn="l" indent="0" marL="0">
-              <a:lnSpc>
-                <a:spcPts val="1860"/>
-              </a:lnSpc>
-              <a:buNone/>
-            </a:pPr>
+              <a:t>grafo.add_edge(START, </a:t>
+            </a:r>
             <a:r>
               <a:rPr lang="en-US" sz="1200" dirty="0">
                 <a:solidFill>
-                  <a:srgbClr val="F4F1EA"/>
+                  <a:srgbClr val="5BA8E6"/>
                 </a:solidFill>
                 <a:latin typeface="Courier New" pitchFamily="49" charset="0"/>
                 <a:ea typeface="Courier New" pitchFamily="49" charset="-122"/>
                 <a:cs typeface="Courier New" pitchFamily="49" charset="-120"/>
               </a:rPr>
-              <a:t>grafo.add_edge(</a:t>
+              <a:t>"auditor"</a:t>
             </a:r>
             <a:r>
               <a:rPr lang="en-US" sz="1200" dirty="0">
                 <a:solidFill>
-                  <a:srgbClr val="5BA8E6"/>
+                  <a:srgbClr val="F4F1EA"/>
                 </a:solidFill>
                 <a:latin typeface="Courier New" pitchFamily="49" charset="0"/>
                 <a:ea typeface="Courier New" pitchFamily="49" charset="-122"/>
                 <a:cs typeface="Courier New" pitchFamily="49" charset="-120"/>
               </a:rPr>
-              <a:t>"auditor"</a:t>
-            </a:r>
+              <a:t>)</a:t>
+            </a:r>
+            <a:endParaRPr lang="en-US" sz="1200" dirty="0"/>
+          </a:p>
+          <a:p>
+            <a:pPr algn="l" indent="0" marL="0">
+              <a:lnSpc>
+                <a:spcPts val="1860"/>
+              </a:lnSpc>
+              <a:buNone/>
+            </a:pPr>
             <a:r>
               <a:rPr lang="en-US" sz="1200" dirty="0">
                 <a:solidFill>
@@ -4522,7 +5025,7 @@
                 <a:ea typeface="Courier New" pitchFamily="49" charset="-122"/>
                 <a:cs typeface="Courier New" pitchFamily="49" charset="-120"/>
               </a:rPr>
-              <a:t>, </a:t>
+              <a:t>grafo.add_edge(</a:t>
             </a:r>
             <a:r>
               <a:rPr lang="en-US" sz="1200" dirty="0">
@@ -4533,7 +5036,7 @@
                 <a:ea typeface="Courier New" pitchFamily="49" charset="-122"/>
                 <a:cs typeface="Courier New" pitchFamily="49" charset="-120"/>
               </a:rPr>
-              <a:t>"consultor_ux"</a:t>
+              <a:t>"auditor"</a:t>
             </a:r>
             <a:r>
               <a:rPr lang="en-US" sz="1200" dirty="0">
@@ -4544,38 +5047,124 @@
                 <a:ea typeface="Courier New" pitchFamily="49" charset="-122"/>
                 <a:cs typeface="Courier New" pitchFamily="49" charset="-120"/>
               </a:rPr>
-              <a:t>)</a:t>
-            </a:r>
-            <a:endParaRPr lang="en-US" sz="1200" dirty="0"/>
-          </a:p>
-          <a:p>
-            <a:pPr algn="l" indent="0" marL="0">
-              <a:lnSpc>
-                <a:spcPts val="1860"/>
-              </a:lnSpc>
-              <a:buNone/>
-            </a:pPr>
+              <a:t>, </a:t>
+            </a:r>
             <a:r>
               <a:rPr lang="en-US" sz="1200" dirty="0">
                 <a:solidFill>
-                  <a:srgbClr val="F4F1EA"/>
+                  <a:srgbClr val="5BA8E6"/>
                 </a:solidFill>
                 <a:latin typeface="Courier New" pitchFamily="49" charset="0"/>
                 <a:ea typeface="Courier New" pitchFamily="49" charset="-122"/>
                 <a:cs typeface="Courier New" pitchFamily="49" charset="-120"/>
               </a:rPr>
-              <a:t>grafo.add_edge(</a:t>
+              <a:t>"consultor_ux"</a:t>
             </a:r>
             <a:r>
               <a:rPr lang="en-US" sz="1200" dirty="0">
                 <a:solidFill>
-                  <a:srgbClr val="5BA8E6"/>
+                  <a:srgbClr val="F4F1EA"/>
                 </a:solidFill>
                 <a:latin typeface="Courier New" pitchFamily="49" charset="0"/>
                 <a:ea typeface="Courier New" pitchFamily="49" charset="-122"/>
                 <a:cs typeface="Courier New" pitchFamily="49" charset="-120"/>
               </a:rPr>
+              <a:t>)</a:t>
+            </a:r>
+            <a:endParaRPr lang="en-US" sz="1200" dirty="0"/>
+          </a:p>
+          <a:p>
+            <a:pPr algn="l" indent="0" marL="0">
+              <a:lnSpc>
+                <a:spcPts val="1860"/>
+              </a:lnSpc>
+              <a:buNone/>
+            </a:pPr>
+            <a:r>
+              <a:rPr lang="en-US" sz="1200" dirty="0">
+                <a:solidFill>
+                  <a:srgbClr val="F4F1EA"/>
+                </a:solidFill>
+                <a:latin typeface="Courier New" pitchFamily="49" charset="0"/>
+                <a:ea typeface="Courier New" pitchFamily="49" charset="-122"/>
+                <a:cs typeface="Courier New" pitchFamily="49" charset="-120"/>
+              </a:rPr>
+              <a:t>grafo.add_edge(</a:t>
+            </a:r>
+            <a:r>
+              <a:rPr lang="en-US" sz="1200" dirty="0">
+                <a:solidFill>
+                  <a:srgbClr val="5BA8E6"/>
+                </a:solidFill>
+                <a:latin typeface="Courier New" pitchFamily="49" charset="0"/>
+                <a:ea typeface="Courier New" pitchFamily="49" charset="-122"/>
+                <a:cs typeface="Courier New" pitchFamily="49" charset="-120"/>
+              </a:rPr>
               <a:t>"consultor_ux"</a:t>
+            </a:r>
+            <a:r>
+              <a:rPr lang="en-US" sz="1200" dirty="0">
+                <a:solidFill>
+                  <a:srgbClr val="F4F1EA"/>
+                </a:solidFill>
+                <a:latin typeface="Courier New" pitchFamily="49" charset="0"/>
+                <a:ea typeface="Courier New" pitchFamily="49" charset="-122"/>
+                <a:cs typeface="Courier New" pitchFamily="49" charset="-120"/>
+              </a:rPr>
+              <a:t>, </a:t>
+            </a:r>
+            <a:r>
+              <a:rPr lang="en-US" sz="1200" dirty="0">
+                <a:solidFill>
+                  <a:srgbClr val="5BA8E6"/>
+                </a:solidFill>
+                <a:latin typeface="Courier New" pitchFamily="49" charset="0"/>
+                <a:ea typeface="Courier New" pitchFamily="49" charset="-122"/>
+                <a:cs typeface="Courier New" pitchFamily="49" charset="-120"/>
+              </a:rPr>
+              <a:t>"verificador"</a:t>
+            </a:r>
+            <a:r>
+              <a:rPr lang="en-US" sz="1200" dirty="0">
+                <a:solidFill>
+                  <a:srgbClr val="F4F1EA"/>
+                </a:solidFill>
+                <a:latin typeface="Courier New" pitchFamily="49" charset="0"/>
+                <a:ea typeface="Courier New" pitchFamily="49" charset="-122"/>
+                <a:cs typeface="Courier New" pitchFamily="49" charset="-120"/>
+              </a:rPr>
+              <a:t>)</a:t>
+            </a:r>
+            <a:endParaRPr lang="en-US" sz="1200" dirty="0"/>
+          </a:p>
+          <a:p>
+            <a:pPr algn="l" indent="0" marL="0">
+              <a:lnSpc>
+                <a:spcPts val="1860"/>
+              </a:lnSpc>
+              <a:buNone/>
+            </a:pPr>
+            <a:r>
+              <a:rPr lang="en-US" sz="1200" dirty="0">
+                <a:solidFill>
+                  <a:srgbClr val="F4F1EA"/>
+                </a:solidFill>
+                <a:latin typeface="Courier New" pitchFamily="49" charset="0"/>
+                <a:ea typeface="Courier New" pitchFamily="49" charset="-122"/>
+                <a:cs typeface="Courier New" pitchFamily="49" charset="-120"/>
+              </a:rPr>
+              <a:t>grafo.add_edge(</a:t>
+            </a:r>
+            <a:r>
+              <a:rPr lang="en-US" sz="1200" dirty="0">
+                <a:solidFill>
+                  <a:srgbClr val="5BA8E6"/>
+                </a:solidFill>
+                <a:latin typeface="Courier New" pitchFamily="49" charset="0"/>
+                <a:ea typeface="Courier New" pitchFamily="49" charset="-122"/>
+                <a:cs typeface="Courier New" pitchFamily="49" charset="-120"/>
+              </a:rPr>
+              <a:t>"verificador"</a:t>
             </a:r>
             <a:r>
               <a:rPr lang="en-US" sz="1200" dirty="0">
@@ -4826,7 +5415,7 @@
                 <a:ea typeface="Helvetica" pitchFamily="34" charset="-122"/>
                 <a:cs typeface="Helvetica" pitchFamily="34" charset="-120"/>
               </a:rPr>
-              <a:t>O Auditor é instruído a não recalcular. O Consultor, a não aprovar cor sem calcular.</a:t>
+              <a:t>O Auditor não recalcula. O Consultor não informa contraste de cores novas.</a:t>
             </a:r>
             <a:endParaRPr lang="en-US" sz="1300" dirty="0"/>
           </a:p>
@@ -4936,7 +5525,7 @@
                 <a:ea typeface="Helvetica" pitchFamily="34" charset="-122"/>
                 <a:cs typeface="Helvetica" pitchFamily="34" charset="-120"/>
               </a:rPr>
-              <a:t>Nós são os agentes e arestas são a sequência. compile() gera a aplicação, e invoke(entrada) executa do início ao fim.</a:t>
+              <a:t>Nós são as etapas e arestas são a sequência. compile() gera a aplicação, e invoke(entrada) executa do início ao fim.</a:t>
             </a:r>
             <a:endParaRPr lang="en-US" sz="1300" dirty="0"/>
           </a:p>
@@ -6198,7 +6787,7 @@
                 <a:ea typeface="Helvetica" pitchFamily="34" charset="-122"/>
                 <a:cs typeface="Helvetica" pitchFamily="34" charset="-120"/>
               </a:rPr>
-              <a:t>Conclusões</a:t>
+              <a:t>Limitação encontrada no Consultor</a:t>
             </a:r>
             <a:endParaRPr lang="en-US" sz="3600" dirty="0"/>
           </a:p>
@@ -6212,12 +6801,12 @@
         </p:nvSpPr>
         <p:spPr>
           <a:xfrm>
-            <a:off x="812800" y="1620521"/>
-            <a:ext cx="3386667" cy="2324100"/>
+            <a:off x="812800" y="1569721"/>
+            <a:ext cx="5883592" cy="2771140"/>
           </a:xfrm>
           <a:prstGeom prst="roundRect">
             <a:avLst>
-              <a:gd name="adj" fmla="val 4372"/>
+              <a:gd name="adj" fmla="val 3666"/>
             </a:avLst>
           </a:prstGeom>
           <a:solidFill>
@@ -6234,8 +6823,8 @@
         </p:nvSpPr>
         <p:spPr>
           <a:xfrm>
-            <a:off x="1066800" y="1874521"/>
-            <a:ext cx="2965027" cy="299720"/>
+            <a:off x="1066800" y="1798321"/>
+            <a:ext cx="5536860" cy="269240"/>
           </a:xfrm>
           <a:prstGeom prst="rect">
             <a:avLst/>
@@ -6251,12 +6840,12 @@
           <a:p>
             <a:pPr algn="l" indent="0" marL="0">
               <a:lnSpc>
-                <a:spcPts val="2160"/>
-              </a:lnSpc>
-              <a:buNone/>
-            </a:pPr>
-            <a:r>
-              <a:rPr lang="en-US" sz="1800" b="1" dirty="0">
+                <a:spcPts val="1920"/>
+              </a:lnSpc>
+              <a:buNone/>
+            </a:pPr>
+            <a:r>
+              <a:rPr lang="en-US" sz="1600" b="1" dirty="0">
                 <a:solidFill>
                   <a:srgbClr val="F2B84B"/>
                 </a:solidFill>
@@ -6264,70 +6853,1096 @@
                 <a:ea typeface="Helvetica" pitchFamily="34" charset="-122"/>
                 <a:cs typeface="Helvetica" pitchFamily="34" charset="-120"/>
               </a:rPr>
-              <a:t>O que funcionou</a:t>
-            </a:r>
-            <a:endParaRPr lang="en-US" sz="1800" dirty="0"/>
-          </a:p>
-        </p:txBody>
-      </p:sp>
-      <p:sp>
-        <p:nvSpPr>
-          <p:cNvPr id="5" name="Text 3"/>
+              <a:t>Contraste informado × calculado</a:t>
+            </a:r>
+            <a:endParaRPr lang="en-US" sz="1600" dirty="0"/>
+          </a:p>
+        </p:txBody>
+      </p:sp>
+      <p:graphicFrame>
+        <p:nvGraphicFramePr>
+          <p:cNvPr id="5" name="Table 0"/>
+          <p:cNvGraphicFramePr>
+            <a:graphicFrameLocks noGrp="1"/>
+          </p:cNvGraphicFramePr>
+          <p:nvPr>
+            <p:extLst>
+              <p:ext uri="{D42A27DB-BD31-4B8C-83A1-F6EECF244321}">
+                <p14:modId xmlns:p14="http://schemas.microsoft.com/office/powerpoint/2010/main" val="1579011935"/>
+              </p:ext>
+            </p:extLst>
+          </p:nvPr>
+        </p:nvGraphicFramePr>
+        <p:xfrm>
+          <a:off x="1079500" y="2181861"/>
+          <a:ext cx="5362892" cy="1930400"/>
+        </p:xfrm>
+        <a:graphic>
+          <a:graphicData uri="http://schemas.openxmlformats.org/drawingml/2006/table">
+            <a:tbl>
+              <a:tblPr/>
+              <a:tblGrid>
+                <a:gridCol w="1787631"/>
+                <a:gridCol w="1787631"/>
+                <a:gridCol w="1787631"/>
+              </a:tblGrid>
+              <a:tr h="386080">
+                <a:tc>
+                  <a:txBody>
+                    <a:bodyPr/>
+                    <a:lstStyle/>
+                    <a:p>
+                      <a:pPr indent="0" marL="0">
+                        <a:lnSpc>
+                          <a:spcPts val="1960"/>
+                        </a:lnSpc>
+                        <a:buNone/>
+                      </a:pPr>
+                      <a:r>
+                        <a:rPr lang="en-US" sz="1400" b="1" dirty="0">
+                          <a:solidFill>
+                            <a:srgbClr val="F4F1EA"/>
+                          </a:solidFill>
+                          <a:latin typeface="Helvetica" pitchFamily="34" charset="0"/>
+                          <a:ea typeface="Helvetica" pitchFamily="34" charset="-122"/>
+                          <a:cs typeface="Helvetica" pitchFamily="34" charset="-120"/>
+                        </a:rPr>
+                        <a:t>Cor sugerida</a:t>
+                      </a:r>
+                      <a:endParaRPr lang="en-US" sz="1400" dirty="0">
+                        <a:latin typeface="Helvetica" charset="0"/>
+                        <a:ea typeface="Helvetica" charset="0"/>
+                        <a:cs typeface="Helvetica" charset="0"/>
+                      </a:endParaRPr>
+                    </a:p>
+                  </a:txBody>
+                  <a:tcPr marL="62230" marR="62230" marT="62230" marB="62230" anchor="t">
+                    <a:lnL w="12700" cap="flat" cmpd="sng" algn="ctr">
+                      <a:solidFill>
+                        <a:srgbClr val="4C5869"/>
+                      </a:solidFill>
+                      <a:prstDash val="solid"/>
+                      <a:round/>
+                      <a:headEnd type="none" w="med" len="med"/>
+                      <a:tailEnd type="none" w="med" len="med"/>
+                    </a:lnL>
+                    <a:lnR w="12700" cap="flat" cmpd="sng" algn="ctr">
+                      <a:solidFill>
+                        <a:srgbClr val="5A6574"/>
+                      </a:solidFill>
+                      <a:prstDash val="solid"/>
+                      <a:round/>
+                      <a:headEnd type="none" w="med" len="med"/>
+                      <a:tailEnd type="none" w="med" len="med"/>
+                    </a:lnR>
+                    <a:lnT w="12700" cap="flat" cmpd="sng" algn="ctr">
+                      <a:solidFill>
+                        <a:srgbClr val="4C5869"/>
+                      </a:solidFill>
+                      <a:prstDash val="solid"/>
+                      <a:round/>
+                      <a:headEnd type="none" w="med" len="med"/>
+                      <a:tailEnd type="none" w="med" len="med"/>
+                    </a:lnT>
+                    <a:lnB w="12700" cap="flat" cmpd="sng" algn="ctr">
+                      <a:solidFill>
+                        <a:srgbClr val="5A6574"/>
+                      </a:solidFill>
+                      <a:prstDash val="solid"/>
+                      <a:round/>
+                      <a:headEnd type="none" w="med" len="med"/>
+                      <a:tailEnd type="none" w="med" len="med"/>
+                    </a:lnB>
+                    <a:solidFill>
+                      <a:srgbClr val="2D3B4F"/>
+                    </a:solidFill>
+                  </a:tcPr>
+                </a:tc>
+                <a:tc>
+                  <a:txBody>
+                    <a:bodyPr/>
+                    <a:lstStyle/>
+                    <a:p>
+                      <a:pPr indent="0" marL="0">
+                        <a:lnSpc>
+                          <a:spcPts val="1960"/>
+                        </a:lnSpc>
+                        <a:buNone/>
+                      </a:pPr>
+                      <a:r>
+                        <a:rPr lang="en-US" sz="1400" b="1" dirty="0">
+                          <a:solidFill>
+                            <a:srgbClr val="F4F1EA"/>
+                          </a:solidFill>
+                          <a:latin typeface="Helvetica" pitchFamily="34" charset="0"/>
+                          <a:ea typeface="Helvetica" pitchFamily="34" charset="-122"/>
+                          <a:cs typeface="Helvetica" pitchFamily="34" charset="-120"/>
+                        </a:rPr>
+                        <a:t>Dito pelo LLM</a:t>
+                      </a:r>
+                      <a:endParaRPr lang="en-US" sz="1400" dirty="0">
+                        <a:latin typeface="Helvetica" charset="0"/>
+                        <a:ea typeface="Helvetica" charset="0"/>
+                        <a:cs typeface="Helvetica" charset="0"/>
+                      </a:endParaRPr>
+                    </a:p>
+                  </a:txBody>
+                  <a:tcPr marL="62230" marR="62230" marT="62230" marB="62230" anchor="t">
+                    <a:lnL w="12700" cap="flat" cmpd="sng" algn="ctr">
+                      <a:solidFill>
+                        <a:srgbClr val="5A6574"/>
+                      </a:solidFill>
+                      <a:prstDash val="solid"/>
+                      <a:round/>
+                      <a:headEnd type="none" w="med" len="med"/>
+                      <a:tailEnd type="none" w="med" len="med"/>
+                    </a:lnL>
+                    <a:lnR w="12700" cap="flat" cmpd="sng" algn="ctr">
+                      <a:solidFill>
+                        <a:srgbClr val="5A6574"/>
+                      </a:solidFill>
+                      <a:prstDash val="solid"/>
+                      <a:round/>
+                      <a:headEnd type="none" w="med" len="med"/>
+                      <a:tailEnd type="none" w="med" len="med"/>
+                    </a:lnR>
+                    <a:lnT w="12700" cap="flat" cmpd="sng" algn="ctr">
+                      <a:solidFill>
+                        <a:srgbClr val="4C5869"/>
+                      </a:solidFill>
+                      <a:prstDash val="solid"/>
+                      <a:round/>
+                      <a:headEnd type="none" w="med" len="med"/>
+                      <a:tailEnd type="none" w="med" len="med"/>
+                    </a:lnT>
+                    <a:lnB w="12700" cap="flat" cmpd="sng" algn="ctr">
+                      <a:solidFill>
+                        <a:srgbClr val="5A6574"/>
+                      </a:solidFill>
+                      <a:prstDash val="solid"/>
+                      <a:round/>
+                      <a:headEnd type="none" w="med" len="med"/>
+                      <a:tailEnd type="none" w="med" len="med"/>
+                    </a:lnB>
+                    <a:solidFill>
+                      <a:srgbClr val="2D3B4F"/>
+                    </a:solidFill>
+                  </a:tcPr>
+                </a:tc>
+                <a:tc>
+                  <a:txBody>
+                    <a:bodyPr/>
+                    <a:lstStyle/>
+                    <a:p>
+                      <a:pPr indent="0" marL="0">
+                        <a:lnSpc>
+                          <a:spcPts val="1960"/>
+                        </a:lnSpc>
+                        <a:buNone/>
+                      </a:pPr>
+                      <a:r>
+                        <a:rPr lang="en-US" sz="1400" b="1" dirty="0">
+                          <a:solidFill>
+                            <a:srgbClr val="F4F1EA"/>
+                          </a:solidFill>
+                          <a:latin typeface="Helvetica" pitchFamily="34" charset="0"/>
+                          <a:ea typeface="Helvetica" pitchFamily="34" charset="-122"/>
+                          <a:cs typeface="Helvetica" pitchFamily="34" charset="-120"/>
+                        </a:rPr>
+                        <a:t>Calculado</a:t>
+                      </a:r>
+                      <a:endParaRPr lang="en-US" sz="1400" dirty="0">
+                        <a:latin typeface="Helvetica" charset="0"/>
+                        <a:ea typeface="Helvetica" charset="0"/>
+                        <a:cs typeface="Helvetica" charset="0"/>
+                      </a:endParaRPr>
+                    </a:p>
+                  </a:txBody>
+                  <a:tcPr marL="62230" marR="62230" marT="62230" marB="62230" anchor="t">
+                    <a:lnL w="12700" cap="flat" cmpd="sng" algn="ctr">
+                      <a:solidFill>
+                        <a:srgbClr val="5A6574"/>
+                      </a:solidFill>
+                      <a:prstDash val="solid"/>
+                      <a:round/>
+                      <a:headEnd type="none" w="med" len="med"/>
+                      <a:tailEnd type="none" w="med" len="med"/>
+                    </a:lnL>
+                    <a:lnR w="12700" cap="flat" cmpd="sng" algn="ctr">
+                      <a:solidFill>
+                        <a:srgbClr val="5A6574"/>
+                      </a:solidFill>
+                      <a:prstDash val="solid"/>
+                      <a:round/>
+                      <a:headEnd type="none" w="med" len="med"/>
+                      <a:tailEnd type="none" w="med" len="med"/>
+                    </a:lnR>
+                    <a:lnT w="12700" cap="flat" cmpd="sng" algn="ctr">
+                      <a:solidFill>
+                        <a:srgbClr val="4C5869"/>
+                      </a:solidFill>
+                      <a:prstDash val="solid"/>
+                      <a:round/>
+                      <a:headEnd type="none" w="med" len="med"/>
+                      <a:tailEnd type="none" w="med" len="med"/>
+                    </a:lnT>
+                    <a:lnB w="12700" cap="flat" cmpd="sng" algn="ctr">
+                      <a:solidFill>
+                        <a:srgbClr val="5A6574"/>
+                      </a:solidFill>
+                      <a:prstDash val="solid"/>
+                      <a:round/>
+                      <a:headEnd type="none" w="med" len="med"/>
+                      <a:tailEnd type="none" w="med" len="med"/>
+                    </a:lnB>
+                    <a:solidFill>
+                      <a:srgbClr val="2D3B4F"/>
+                    </a:solidFill>
+                  </a:tcPr>
+                </a:tc>
+              </a:tr>
+              <a:tr h="386080">
+                <a:tc>
+                  <a:txBody>
+                    <a:bodyPr/>
+                    <a:lstStyle/>
+                    <a:p>
+                      <a:pPr indent="0" marL="0">
+                        <a:lnSpc>
+                          <a:spcPts val="1960"/>
+                        </a:lnSpc>
+                        <a:buNone/>
+                      </a:pPr>
+                      <a:r>
+                        <a:rPr lang="en-US" sz="1400" dirty="0">
+                          <a:solidFill>
+                            <a:srgbClr val="F4F1EA"/>
+                          </a:solidFill>
+                          <a:latin typeface="Helvetica" pitchFamily="34" charset="0"/>
+                          <a:ea typeface="Helvetica" pitchFamily="34" charset="-122"/>
+                          <a:cs typeface="Helvetica" pitchFamily="34" charset="-120"/>
+                        </a:rPr>
+                        <a:t>#6A6A6A / branco</a:t>
+                      </a:r>
+                      <a:endParaRPr lang="en-US" sz="1400" dirty="0">
+                        <a:latin typeface="Helvetica" charset="0"/>
+                        <a:ea typeface="Helvetica" charset="0"/>
+                        <a:cs typeface="Helvetica" charset="0"/>
+                      </a:endParaRPr>
+                    </a:p>
+                  </a:txBody>
+                  <a:tcPr marL="62230" marR="62230" marT="62230" marB="62230" anchor="t">
+                    <a:lnL w="12700" cap="flat" cmpd="sng" algn="ctr">
+                      <a:solidFill>
+                        <a:srgbClr val="4C5869"/>
+                      </a:solidFill>
+                      <a:prstDash val="solid"/>
+                      <a:round/>
+                      <a:headEnd type="none" w="med" len="med"/>
+                      <a:tailEnd type="none" w="med" len="med"/>
+                    </a:lnL>
+                    <a:lnR w="12700" cap="flat" cmpd="sng" algn="ctr">
+                      <a:solidFill>
+                        <a:srgbClr val="4C5869"/>
+                      </a:solidFill>
+                      <a:prstDash val="solid"/>
+                      <a:round/>
+                      <a:headEnd type="none" w="med" len="med"/>
+                      <a:tailEnd type="none" w="med" len="med"/>
+                    </a:lnR>
+                    <a:lnT w="12700" cap="flat" cmpd="sng" algn="ctr">
+                      <a:solidFill>
+                        <a:srgbClr val="5A6574"/>
+                      </a:solidFill>
+                      <a:prstDash val="solid"/>
+                      <a:round/>
+                      <a:headEnd type="none" w="med" len="med"/>
+                      <a:tailEnd type="none" w="med" len="med"/>
+                    </a:lnT>
+                    <a:lnB w="12700" cap="flat" cmpd="sng" algn="ctr">
+                      <a:solidFill>
+                        <a:srgbClr val="4C5869"/>
+                      </a:solidFill>
+                      <a:prstDash val="solid"/>
+                      <a:round/>
+                      <a:headEnd type="none" w="med" len="med"/>
+                      <a:tailEnd type="none" w="med" len="med"/>
+                    </a:lnB>
+                  </a:tcPr>
+                </a:tc>
+                <a:tc>
+                  <a:txBody>
+                    <a:bodyPr/>
+                    <a:lstStyle/>
+                    <a:p>
+                      <a:pPr indent="0" marL="0">
+                        <a:lnSpc>
+                          <a:spcPts val="1960"/>
+                        </a:lnSpc>
+                        <a:buNone/>
+                      </a:pPr>
+                      <a:r>
+                        <a:rPr lang="en-US" sz="1400" dirty="0">
+                          <a:solidFill>
+                            <a:srgbClr val="F4F1EA"/>
+                          </a:solidFill>
+                          <a:latin typeface="Helvetica" pitchFamily="34" charset="0"/>
+                          <a:ea typeface="Helvetica" pitchFamily="34" charset="-122"/>
+                          <a:cs typeface="Helvetica" pitchFamily="34" charset="-120"/>
+                        </a:rPr>
+                        <a:t>4,71:1</a:t>
+                      </a:r>
+                      <a:endParaRPr lang="en-US" sz="1400" dirty="0">
+                        <a:latin typeface="Helvetica" charset="0"/>
+                        <a:ea typeface="Helvetica" charset="0"/>
+                        <a:cs typeface="Helvetica" charset="0"/>
+                      </a:endParaRPr>
+                    </a:p>
+                  </a:txBody>
+                  <a:tcPr marL="62230" marR="62230" marT="62230" marB="62230" anchor="t">
+                    <a:lnL w="12700" cap="flat" cmpd="sng" algn="ctr">
+                      <a:solidFill>
+                        <a:srgbClr val="4C5869"/>
+                      </a:solidFill>
+                      <a:prstDash val="solid"/>
+                      <a:round/>
+                      <a:headEnd type="none" w="med" len="med"/>
+                      <a:tailEnd type="none" w="med" len="med"/>
+                    </a:lnL>
+                    <a:lnR w="12700" cap="flat" cmpd="sng" algn="ctr">
+                      <a:solidFill>
+                        <a:srgbClr val="4C5869"/>
+                      </a:solidFill>
+                      <a:prstDash val="solid"/>
+                      <a:round/>
+                      <a:headEnd type="none" w="med" len="med"/>
+                      <a:tailEnd type="none" w="med" len="med"/>
+                    </a:lnR>
+                    <a:lnT w="12700" cap="flat" cmpd="sng" algn="ctr">
+                      <a:solidFill>
+                        <a:srgbClr val="5A6574"/>
+                      </a:solidFill>
+                      <a:prstDash val="solid"/>
+                      <a:round/>
+                      <a:headEnd type="none" w="med" len="med"/>
+                      <a:tailEnd type="none" w="med" len="med"/>
+                    </a:lnT>
+                    <a:lnB w="12700" cap="flat" cmpd="sng" algn="ctr">
+                      <a:solidFill>
+                        <a:srgbClr val="4C5869"/>
+                      </a:solidFill>
+                      <a:prstDash val="solid"/>
+                      <a:round/>
+                      <a:headEnd type="none" w="med" len="med"/>
+                      <a:tailEnd type="none" w="med" len="med"/>
+                    </a:lnB>
+                  </a:tcPr>
+                </a:tc>
+                <a:tc>
+                  <a:txBody>
+                    <a:bodyPr/>
+                    <a:lstStyle/>
+                    <a:p>
+                      <a:pPr indent="0" marL="0">
+                        <a:lnSpc>
+                          <a:spcPts val="1960"/>
+                        </a:lnSpc>
+                        <a:buNone/>
+                      </a:pPr>
+                      <a:r>
+                        <a:rPr lang="en-US" sz="1400" dirty="0">
+                          <a:solidFill>
+                            <a:srgbClr val="F4F1EA"/>
+                          </a:solidFill>
+                          <a:latin typeface="Helvetica" pitchFamily="34" charset="0"/>
+                          <a:ea typeface="Helvetica" pitchFamily="34" charset="-122"/>
+                          <a:cs typeface="Helvetica" pitchFamily="34" charset="-120"/>
+                        </a:rPr>
+                        <a:t>5,41:1</a:t>
+                      </a:r>
+                      <a:endParaRPr lang="en-US" sz="1400" dirty="0">
+                        <a:latin typeface="Helvetica" charset="0"/>
+                        <a:ea typeface="Helvetica" charset="0"/>
+                        <a:cs typeface="Helvetica" charset="0"/>
+                      </a:endParaRPr>
+                    </a:p>
+                  </a:txBody>
+                  <a:tcPr marL="62230" marR="62230" marT="62230" marB="62230" anchor="t">
+                    <a:lnL w="12700" cap="flat" cmpd="sng" algn="ctr">
+                      <a:solidFill>
+                        <a:srgbClr val="4C5869"/>
+                      </a:solidFill>
+                      <a:prstDash val="solid"/>
+                      <a:round/>
+                      <a:headEnd type="none" w="med" len="med"/>
+                      <a:tailEnd type="none" w="med" len="med"/>
+                    </a:lnL>
+                    <a:lnR w="12700" cap="flat" cmpd="sng" algn="ctr">
+                      <a:solidFill>
+                        <a:srgbClr val="4C5869"/>
+                      </a:solidFill>
+                      <a:prstDash val="solid"/>
+                      <a:round/>
+                      <a:headEnd type="none" w="med" len="med"/>
+                      <a:tailEnd type="none" w="med" len="med"/>
+                    </a:lnR>
+                    <a:lnT w="12700" cap="flat" cmpd="sng" algn="ctr">
+                      <a:solidFill>
+                        <a:srgbClr val="5A6574"/>
+                      </a:solidFill>
+                      <a:prstDash val="solid"/>
+                      <a:round/>
+                      <a:headEnd type="none" w="med" len="med"/>
+                      <a:tailEnd type="none" w="med" len="med"/>
+                    </a:lnT>
+                    <a:lnB w="12700" cap="flat" cmpd="sng" algn="ctr">
+                      <a:solidFill>
+                        <a:srgbClr val="4C5869"/>
+                      </a:solidFill>
+                      <a:prstDash val="solid"/>
+                      <a:round/>
+                      <a:headEnd type="none" w="med" len="med"/>
+                      <a:tailEnd type="none" w="med" len="med"/>
+                    </a:lnB>
+                  </a:tcPr>
+                </a:tc>
+              </a:tr>
+              <a:tr h="386080">
+                <a:tc>
+                  <a:txBody>
+                    <a:bodyPr/>
+                    <a:lstStyle/>
+                    <a:p>
+                      <a:pPr indent="0" marL="0">
+                        <a:lnSpc>
+                          <a:spcPts val="1960"/>
+                        </a:lnSpc>
+                        <a:buNone/>
+                      </a:pPr>
+                      <a:r>
+                        <a:rPr lang="en-US" sz="1400" dirty="0">
+                          <a:solidFill>
+                            <a:srgbClr val="F4F1EA"/>
+                          </a:solidFill>
+                          <a:latin typeface="Helvetica" pitchFamily="34" charset="0"/>
+                          <a:ea typeface="Helvetica" pitchFamily="34" charset="-122"/>
+                          <a:cs typeface="Helvetica" pitchFamily="34" charset="-120"/>
+                        </a:rPr>
+                        <a:t>#4D4D4D / branco</a:t>
+                      </a:r>
+                      <a:endParaRPr lang="en-US" sz="1400" dirty="0">
+                        <a:latin typeface="Helvetica" charset="0"/>
+                        <a:ea typeface="Helvetica" charset="0"/>
+                        <a:cs typeface="Helvetica" charset="0"/>
+                      </a:endParaRPr>
+                    </a:p>
+                  </a:txBody>
+                  <a:tcPr marL="62230" marR="62230" marT="62230" marB="62230" anchor="t">
+                    <a:lnL w="12700" cap="flat" cmpd="sng" algn="ctr">
+                      <a:solidFill>
+                        <a:srgbClr val="4C5869"/>
+                      </a:solidFill>
+                      <a:prstDash val="solid"/>
+                      <a:round/>
+                      <a:headEnd type="none" w="med" len="med"/>
+                      <a:tailEnd type="none" w="med" len="med"/>
+                    </a:lnL>
+                    <a:lnR w="12700" cap="flat" cmpd="sng" algn="ctr">
+                      <a:solidFill>
+                        <a:srgbClr val="4C5869"/>
+                      </a:solidFill>
+                      <a:prstDash val="solid"/>
+                      <a:round/>
+                      <a:headEnd type="none" w="med" len="med"/>
+                      <a:tailEnd type="none" w="med" len="med"/>
+                    </a:lnR>
+                    <a:lnT w="12700" cap="flat" cmpd="sng" algn="ctr">
+                      <a:solidFill>
+                        <a:srgbClr val="4C5869"/>
+                      </a:solidFill>
+                      <a:prstDash val="solid"/>
+                      <a:round/>
+                      <a:headEnd type="none" w="med" len="med"/>
+                      <a:tailEnd type="none" w="med" len="med"/>
+                    </a:lnT>
+                    <a:lnB w="12700" cap="flat" cmpd="sng" algn="ctr">
+                      <a:solidFill>
+                        <a:srgbClr val="4C5869"/>
+                      </a:solidFill>
+                      <a:prstDash val="solid"/>
+                      <a:round/>
+                      <a:headEnd type="none" w="med" len="med"/>
+                      <a:tailEnd type="none" w="med" len="med"/>
+                    </a:lnB>
+                  </a:tcPr>
+                </a:tc>
+                <a:tc>
+                  <a:txBody>
+                    <a:bodyPr/>
+                    <a:lstStyle/>
+                    <a:p>
+                      <a:pPr indent="0" marL="0">
+                        <a:lnSpc>
+                          <a:spcPts val="1960"/>
+                        </a:lnSpc>
+                        <a:buNone/>
+                      </a:pPr>
+                      <a:r>
+                        <a:rPr lang="en-US" sz="1400" dirty="0">
+                          <a:solidFill>
+                            <a:srgbClr val="F4F1EA"/>
+                          </a:solidFill>
+                          <a:latin typeface="Helvetica" pitchFamily="34" charset="0"/>
+                          <a:ea typeface="Helvetica" pitchFamily="34" charset="-122"/>
+                          <a:cs typeface="Helvetica" pitchFamily="34" charset="-120"/>
+                        </a:rPr>
+                        <a:t>7,95:1</a:t>
+                      </a:r>
+                      <a:endParaRPr lang="en-US" sz="1400" dirty="0">
+                        <a:latin typeface="Helvetica" charset="0"/>
+                        <a:ea typeface="Helvetica" charset="0"/>
+                        <a:cs typeface="Helvetica" charset="0"/>
+                      </a:endParaRPr>
+                    </a:p>
+                  </a:txBody>
+                  <a:tcPr marL="62230" marR="62230" marT="62230" marB="62230" anchor="t">
+                    <a:lnL w="12700" cap="flat" cmpd="sng" algn="ctr">
+                      <a:solidFill>
+                        <a:srgbClr val="4C5869"/>
+                      </a:solidFill>
+                      <a:prstDash val="solid"/>
+                      <a:round/>
+                      <a:headEnd type="none" w="med" len="med"/>
+                      <a:tailEnd type="none" w="med" len="med"/>
+                    </a:lnL>
+                    <a:lnR w="12700" cap="flat" cmpd="sng" algn="ctr">
+                      <a:solidFill>
+                        <a:srgbClr val="4C5869"/>
+                      </a:solidFill>
+                      <a:prstDash val="solid"/>
+                      <a:round/>
+                      <a:headEnd type="none" w="med" len="med"/>
+                      <a:tailEnd type="none" w="med" len="med"/>
+                    </a:lnR>
+                    <a:lnT w="12700" cap="flat" cmpd="sng" algn="ctr">
+                      <a:solidFill>
+                        <a:srgbClr val="4C5869"/>
+                      </a:solidFill>
+                      <a:prstDash val="solid"/>
+                      <a:round/>
+                      <a:headEnd type="none" w="med" len="med"/>
+                      <a:tailEnd type="none" w="med" len="med"/>
+                    </a:lnT>
+                    <a:lnB w="12700" cap="flat" cmpd="sng" algn="ctr">
+                      <a:solidFill>
+                        <a:srgbClr val="4C5869"/>
+                      </a:solidFill>
+                      <a:prstDash val="solid"/>
+                      <a:round/>
+                      <a:headEnd type="none" w="med" len="med"/>
+                      <a:tailEnd type="none" w="med" len="med"/>
+                    </a:lnB>
+                  </a:tcPr>
+                </a:tc>
+                <a:tc>
+                  <a:txBody>
+                    <a:bodyPr/>
+                    <a:lstStyle/>
+                    <a:p>
+                      <a:pPr indent="0" marL="0">
+                        <a:lnSpc>
+                          <a:spcPts val="1960"/>
+                        </a:lnSpc>
+                        <a:buNone/>
+                      </a:pPr>
+                      <a:r>
+                        <a:rPr lang="en-US" sz="1400" dirty="0">
+                          <a:solidFill>
+                            <a:srgbClr val="F4F1EA"/>
+                          </a:solidFill>
+                          <a:latin typeface="Helvetica" pitchFamily="34" charset="0"/>
+                          <a:ea typeface="Helvetica" pitchFamily="34" charset="-122"/>
+                          <a:cs typeface="Helvetica" pitchFamily="34" charset="-120"/>
+                        </a:rPr>
+                        <a:t>8,45:1</a:t>
+                      </a:r>
+                      <a:endParaRPr lang="en-US" sz="1400" dirty="0">
+                        <a:latin typeface="Helvetica" charset="0"/>
+                        <a:ea typeface="Helvetica" charset="0"/>
+                        <a:cs typeface="Helvetica" charset="0"/>
+                      </a:endParaRPr>
+                    </a:p>
+                  </a:txBody>
+                  <a:tcPr marL="62230" marR="62230" marT="62230" marB="62230" anchor="t">
+                    <a:lnL w="12700" cap="flat" cmpd="sng" algn="ctr">
+                      <a:solidFill>
+                        <a:srgbClr val="4C5869"/>
+                      </a:solidFill>
+                      <a:prstDash val="solid"/>
+                      <a:round/>
+                      <a:headEnd type="none" w="med" len="med"/>
+                      <a:tailEnd type="none" w="med" len="med"/>
+                    </a:lnL>
+                    <a:lnR w="12700" cap="flat" cmpd="sng" algn="ctr">
+                      <a:solidFill>
+                        <a:srgbClr val="4C5869"/>
+                      </a:solidFill>
+                      <a:prstDash val="solid"/>
+                      <a:round/>
+                      <a:headEnd type="none" w="med" len="med"/>
+                      <a:tailEnd type="none" w="med" len="med"/>
+                    </a:lnR>
+                    <a:lnT w="12700" cap="flat" cmpd="sng" algn="ctr">
+                      <a:solidFill>
+                        <a:srgbClr val="4C5869"/>
+                      </a:solidFill>
+                      <a:prstDash val="solid"/>
+                      <a:round/>
+                      <a:headEnd type="none" w="med" len="med"/>
+                      <a:tailEnd type="none" w="med" len="med"/>
+                    </a:lnT>
+                    <a:lnB w="12700" cap="flat" cmpd="sng" algn="ctr">
+                      <a:solidFill>
+                        <a:srgbClr val="4C5869"/>
+                      </a:solidFill>
+                      <a:prstDash val="solid"/>
+                      <a:round/>
+                      <a:headEnd type="none" w="med" len="med"/>
+                      <a:tailEnd type="none" w="med" len="med"/>
+                    </a:lnB>
+                  </a:tcPr>
+                </a:tc>
+              </a:tr>
+              <a:tr h="386080">
+                <a:tc>
+                  <a:txBody>
+                    <a:bodyPr/>
+                    <a:lstStyle/>
+                    <a:p>
+                      <a:pPr indent="0" marL="0">
+                        <a:lnSpc>
+                          <a:spcPts val="1960"/>
+                        </a:lnSpc>
+                        <a:buNone/>
+                      </a:pPr>
+                      <a:r>
+                        <a:rPr lang="en-US" sz="1400" dirty="0">
+                          <a:solidFill>
+                            <a:srgbClr val="F4F1EA"/>
+                          </a:solidFill>
+                          <a:latin typeface="Helvetica" pitchFamily="34" charset="0"/>
+                          <a:ea typeface="Helvetica" pitchFamily="34" charset="-122"/>
+                          <a:cs typeface="Helvetica" pitchFamily="34" charset="-120"/>
+                        </a:rPr>
+                        <a:t>#CCCCCC / preto</a:t>
+                      </a:r>
+                      <a:endParaRPr lang="en-US" sz="1400" dirty="0">
+                        <a:latin typeface="Helvetica" charset="0"/>
+                        <a:ea typeface="Helvetica" charset="0"/>
+                        <a:cs typeface="Helvetica" charset="0"/>
+                      </a:endParaRPr>
+                    </a:p>
+                  </a:txBody>
+                  <a:tcPr marL="62230" marR="62230" marT="62230" marB="62230" anchor="t">
+                    <a:lnL w="12700" cap="flat" cmpd="sng" algn="ctr">
+                      <a:solidFill>
+                        <a:srgbClr val="4C5869"/>
+                      </a:solidFill>
+                      <a:prstDash val="solid"/>
+                      <a:round/>
+                      <a:headEnd type="none" w="med" len="med"/>
+                      <a:tailEnd type="none" w="med" len="med"/>
+                    </a:lnL>
+                    <a:lnR w="12700" cap="flat" cmpd="sng" algn="ctr">
+                      <a:solidFill>
+                        <a:srgbClr val="4C5869"/>
+                      </a:solidFill>
+                      <a:prstDash val="solid"/>
+                      <a:round/>
+                      <a:headEnd type="none" w="med" len="med"/>
+                      <a:tailEnd type="none" w="med" len="med"/>
+                    </a:lnR>
+                    <a:lnT w="12700" cap="flat" cmpd="sng" algn="ctr">
+                      <a:solidFill>
+                        <a:srgbClr val="4C5869"/>
+                      </a:solidFill>
+                      <a:prstDash val="solid"/>
+                      <a:round/>
+                      <a:headEnd type="none" w="med" len="med"/>
+                      <a:tailEnd type="none" w="med" len="med"/>
+                    </a:lnT>
+                    <a:lnB w="12700" cap="flat" cmpd="sng" algn="ctr">
+                      <a:solidFill>
+                        <a:srgbClr val="4C5869"/>
+                      </a:solidFill>
+                      <a:prstDash val="solid"/>
+                      <a:round/>
+                      <a:headEnd type="none" w="med" len="med"/>
+                      <a:tailEnd type="none" w="med" len="med"/>
+                    </a:lnB>
+                  </a:tcPr>
+                </a:tc>
+                <a:tc>
+                  <a:txBody>
+                    <a:bodyPr/>
+                    <a:lstStyle/>
+                    <a:p>
+                      <a:pPr indent="0" marL="0">
+                        <a:lnSpc>
+                          <a:spcPts val="1960"/>
+                        </a:lnSpc>
+                        <a:buNone/>
+                      </a:pPr>
+                      <a:r>
+                        <a:rPr lang="en-US" sz="1400" dirty="0">
+                          <a:solidFill>
+                            <a:srgbClr val="F4F1EA"/>
+                          </a:solidFill>
+                          <a:latin typeface="Helvetica" pitchFamily="34" charset="0"/>
+                          <a:ea typeface="Helvetica" pitchFamily="34" charset="-122"/>
+                          <a:cs typeface="Helvetica" pitchFamily="34" charset="-120"/>
+                        </a:rPr>
+                        <a:t>5,36:1</a:t>
+                      </a:r>
+                      <a:endParaRPr lang="en-US" sz="1400" dirty="0">
+                        <a:latin typeface="Helvetica" charset="0"/>
+                        <a:ea typeface="Helvetica" charset="0"/>
+                        <a:cs typeface="Helvetica" charset="0"/>
+                      </a:endParaRPr>
+                    </a:p>
+                  </a:txBody>
+                  <a:tcPr marL="62230" marR="62230" marT="62230" marB="62230" anchor="t">
+                    <a:lnL w="12700" cap="flat" cmpd="sng" algn="ctr">
+                      <a:solidFill>
+                        <a:srgbClr val="4C5869"/>
+                      </a:solidFill>
+                      <a:prstDash val="solid"/>
+                      <a:round/>
+                      <a:headEnd type="none" w="med" len="med"/>
+                      <a:tailEnd type="none" w="med" len="med"/>
+                    </a:lnL>
+                    <a:lnR w="12700" cap="flat" cmpd="sng" algn="ctr">
+                      <a:solidFill>
+                        <a:srgbClr val="4C5869"/>
+                      </a:solidFill>
+                      <a:prstDash val="solid"/>
+                      <a:round/>
+                      <a:headEnd type="none" w="med" len="med"/>
+                      <a:tailEnd type="none" w="med" len="med"/>
+                    </a:lnR>
+                    <a:lnT w="12700" cap="flat" cmpd="sng" algn="ctr">
+                      <a:solidFill>
+                        <a:srgbClr val="4C5869"/>
+                      </a:solidFill>
+                      <a:prstDash val="solid"/>
+                      <a:round/>
+                      <a:headEnd type="none" w="med" len="med"/>
+                      <a:tailEnd type="none" w="med" len="med"/>
+                    </a:lnT>
+                    <a:lnB w="12700" cap="flat" cmpd="sng" algn="ctr">
+                      <a:solidFill>
+                        <a:srgbClr val="4C5869"/>
+                      </a:solidFill>
+                      <a:prstDash val="solid"/>
+                      <a:round/>
+                      <a:headEnd type="none" w="med" len="med"/>
+                      <a:tailEnd type="none" w="med" len="med"/>
+                    </a:lnB>
+                  </a:tcPr>
+                </a:tc>
+                <a:tc>
+                  <a:txBody>
+                    <a:bodyPr/>
+                    <a:lstStyle/>
+                    <a:p>
+                      <a:pPr indent="0" marL="0">
+                        <a:lnSpc>
+                          <a:spcPts val="1960"/>
+                        </a:lnSpc>
+                        <a:buNone/>
+                      </a:pPr>
+                      <a:r>
+                        <a:rPr lang="en-US" sz="1400" dirty="0">
+                          <a:solidFill>
+                            <a:srgbClr val="F4F1EA"/>
+                          </a:solidFill>
+                          <a:latin typeface="Helvetica" pitchFamily="34" charset="0"/>
+                          <a:ea typeface="Helvetica" pitchFamily="34" charset="-122"/>
+                          <a:cs typeface="Helvetica" pitchFamily="34" charset="-120"/>
+                        </a:rPr>
+                        <a:t>13,08:1</a:t>
+                      </a:r>
+                      <a:endParaRPr lang="en-US" sz="1400" dirty="0">
+                        <a:latin typeface="Helvetica" charset="0"/>
+                        <a:ea typeface="Helvetica" charset="0"/>
+                        <a:cs typeface="Helvetica" charset="0"/>
+                      </a:endParaRPr>
+                    </a:p>
+                  </a:txBody>
+                  <a:tcPr marL="62230" marR="62230" marT="62230" marB="62230" anchor="t">
+                    <a:lnL w="12700" cap="flat" cmpd="sng" algn="ctr">
+                      <a:solidFill>
+                        <a:srgbClr val="4C5869"/>
+                      </a:solidFill>
+                      <a:prstDash val="solid"/>
+                      <a:round/>
+                      <a:headEnd type="none" w="med" len="med"/>
+                      <a:tailEnd type="none" w="med" len="med"/>
+                    </a:lnL>
+                    <a:lnR w="12700" cap="flat" cmpd="sng" algn="ctr">
+                      <a:solidFill>
+                        <a:srgbClr val="4C5869"/>
+                      </a:solidFill>
+                      <a:prstDash val="solid"/>
+                      <a:round/>
+                      <a:headEnd type="none" w="med" len="med"/>
+                      <a:tailEnd type="none" w="med" len="med"/>
+                    </a:lnR>
+                    <a:lnT w="12700" cap="flat" cmpd="sng" algn="ctr">
+                      <a:solidFill>
+                        <a:srgbClr val="4C5869"/>
+                      </a:solidFill>
+                      <a:prstDash val="solid"/>
+                      <a:round/>
+                      <a:headEnd type="none" w="med" len="med"/>
+                      <a:tailEnd type="none" w="med" len="med"/>
+                    </a:lnT>
+                    <a:lnB w="12700" cap="flat" cmpd="sng" algn="ctr">
+                      <a:solidFill>
+                        <a:srgbClr val="4C5869"/>
+                      </a:solidFill>
+                      <a:prstDash val="solid"/>
+                      <a:round/>
+                      <a:headEnd type="none" w="med" len="med"/>
+                      <a:tailEnd type="none" w="med" len="med"/>
+                    </a:lnB>
+                  </a:tcPr>
+                </a:tc>
+              </a:tr>
+              <a:tr h="386080">
+                <a:tc>
+                  <a:txBody>
+                    <a:bodyPr/>
+                    <a:lstStyle/>
+                    <a:p>
+                      <a:pPr indent="0" marL="0">
+                        <a:lnSpc>
+                          <a:spcPts val="1960"/>
+                        </a:lnSpc>
+                        <a:buNone/>
+                      </a:pPr>
+                      <a:r>
+                        <a:rPr lang="en-US" sz="1400" dirty="0">
+                          <a:solidFill>
+                            <a:srgbClr val="F4F1EA"/>
+                          </a:solidFill>
+                          <a:latin typeface="Helvetica" pitchFamily="34" charset="0"/>
+                          <a:ea typeface="Helvetica" pitchFamily="34" charset="-122"/>
+                          <a:cs typeface="Helvetica" pitchFamily="34" charset="-120"/>
+                        </a:rPr>
+                        <a:t>#A0A0A0 / preto</a:t>
+                      </a:r>
+                      <a:endParaRPr lang="en-US" sz="1400" dirty="0">
+                        <a:latin typeface="Helvetica" charset="0"/>
+                        <a:ea typeface="Helvetica" charset="0"/>
+                        <a:cs typeface="Helvetica" charset="0"/>
+                      </a:endParaRPr>
+                    </a:p>
+                  </a:txBody>
+                  <a:tcPr marL="62230" marR="62230" marT="62230" marB="62230" anchor="t">
+                    <a:lnL w="12700" cap="flat" cmpd="sng" algn="ctr">
+                      <a:solidFill>
+                        <a:srgbClr val="4C5869"/>
+                      </a:solidFill>
+                      <a:prstDash val="solid"/>
+                      <a:round/>
+                      <a:headEnd type="none" w="med" len="med"/>
+                      <a:tailEnd type="none" w="med" len="med"/>
+                    </a:lnL>
+                    <a:lnR w="12700" cap="flat" cmpd="sng" algn="ctr">
+                      <a:solidFill>
+                        <a:srgbClr val="4C5869"/>
+                      </a:solidFill>
+                      <a:prstDash val="solid"/>
+                      <a:round/>
+                      <a:headEnd type="none" w="med" len="med"/>
+                      <a:tailEnd type="none" w="med" len="med"/>
+                    </a:lnR>
+                    <a:lnT w="12700" cap="flat" cmpd="sng" algn="ctr">
+                      <a:solidFill>
+                        <a:srgbClr val="4C5869"/>
+                      </a:solidFill>
+                      <a:prstDash val="solid"/>
+                      <a:round/>
+                      <a:headEnd type="none" w="med" len="med"/>
+                      <a:tailEnd type="none" w="med" len="med"/>
+                    </a:lnT>
+                    <a:lnB w="12700" cap="flat" cmpd="sng" algn="ctr">
+                      <a:solidFill>
+                        <a:srgbClr val="4C5869"/>
+                      </a:solidFill>
+                      <a:prstDash val="solid"/>
+                      <a:round/>
+                      <a:headEnd type="none" w="med" len="med"/>
+                      <a:tailEnd type="none" w="med" len="med"/>
+                    </a:lnB>
+                  </a:tcPr>
+                </a:tc>
+                <a:tc>
+                  <a:txBody>
+                    <a:bodyPr/>
+                    <a:lstStyle/>
+                    <a:p>
+                      <a:pPr indent="0" marL="0">
+                        <a:lnSpc>
+                          <a:spcPts val="1960"/>
+                        </a:lnSpc>
+                        <a:buNone/>
+                      </a:pPr>
+                      <a:r>
+                        <a:rPr lang="en-US" sz="1400" dirty="0">
+                          <a:solidFill>
+                            <a:srgbClr val="F4F1EA"/>
+                          </a:solidFill>
+                          <a:latin typeface="Helvetica" pitchFamily="34" charset="0"/>
+                          <a:ea typeface="Helvetica" pitchFamily="34" charset="-122"/>
+                          <a:cs typeface="Helvetica" pitchFamily="34" charset="-120"/>
+                        </a:rPr>
+                        <a:t>7,02:1</a:t>
+                      </a:r>
+                      <a:endParaRPr lang="en-US" sz="1400" dirty="0">
+                        <a:latin typeface="Helvetica" charset="0"/>
+                        <a:ea typeface="Helvetica" charset="0"/>
+                        <a:cs typeface="Helvetica" charset="0"/>
+                      </a:endParaRPr>
+                    </a:p>
+                  </a:txBody>
+                  <a:tcPr marL="62230" marR="62230" marT="62230" marB="62230" anchor="t">
+                    <a:lnL w="12700" cap="flat" cmpd="sng" algn="ctr">
+                      <a:solidFill>
+                        <a:srgbClr val="4C5869"/>
+                      </a:solidFill>
+                      <a:prstDash val="solid"/>
+                      <a:round/>
+                      <a:headEnd type="none" w="med" len="med"/>
+                      <a:tailEnd type="none" w="med" len="med"/>
+                    </a:lnL>
+                    <a:lnR w="12700" cap="flat" cmpd="sng" algn="ctr">
+                      <a:solidFill>
+                        <a:srgbClr val="4C5869"/>
+                      </a:solidFill>
+                      <a:prstDash val="solid"/>
+                      <a:round/>
+                      <a:headEnd type="none" w="med" len="med"/>
+                      <a:tailEnd type="none" w="med" len="med"/>
+                    </a:lnR>
+                    <a:lnT w="12700" cap="flat" cmpd="sng" algn="ctr">
+                      <a:solidFill>
+                        <a:srgbClr val="4C5869"/>
+                      </a:solidFill>
+                      <a:prstDash val="solid"/>
+                      <a:round/>
+                      <a:headEnd type="none" w="med" len="med"/>
+                      <a:tailEnd type="none" w="med" len="med"/>
+                    </a:lnT>
+                    <a:lnB w="12700" cap="flat" cmpd="sng" algn="ctr">
+                      <a:solidFill>
+                        <a:srgbClr val="4C5869"/>
+                      </a:solidFill>
+                      <a:prstDash val="solid"/>
+                      <a:round/>
+                      <a:headEnd type="none" w="med" len="med"/>
+                      <a:tailEnd type="none" w="med" len="med"/>
+                    </a:lnB>
+                  </a:tcPr>
+                </a:tc>
+                <a:tc>
+                  <a:txBody>
+                    <a:bodyPr/>
+                    <a:lstStyle/>
+                    <a:p>
+                      <a:pPr indent="0" marL="0">
+                        <a:lnSpc>
+                          <a:spcPts val="1960"/>
+                        </a:lnSpc>
+                        <a:buNone/>
+                      </a:pPr>
+                      <a:r>
+                        <a:rPr lang="en-US" sz="1400" dirty="0">
+                          <a:solidFill>
+                            <a:srgbClr val="F4F1EA"/>
+                          </a:solidFill>
+                          <a:latin typeface="Helvetica" pitchFamily="34" charset="0"/>
+                          <a:ea typeface="Helvetica" pitchFamily="34" charset="-122"/>
+                          <a:cs typeface="Helvetica" pitchFamily="34" charset="-120"/>
+                        </a:rPr>
+                        <a:t>8,03:1</a:t>
+                      </a:r>
+                      <a:endParaRPr lang="en-US" sz="1400" dirty="0">
+                        <a:latin typeface="Helvetica" charset="0"/>
+                        <a:ea typeface="Helvetica" charset="0"/>
+                        <a:cs typeface="Helvetica" charset="0"/>
+                      </a:endParaRPr>
+                    </a:p>
+                  </a:txBody>
+                  <a:tcPr marL="62230" marR="62230" marT="62230" marB="62230" anchor="t">
+                    <a:lnL w="12700" cap="flat" cmpd="sng" algn="ctr">
+                      <a:solidFill>
+                        <a:srgbClr val="4C5869"/>
+                      </a:solidFill>
+                      <a:prstDash val="solid"/>
+                      <a:round/>
+                      <a:headEnd type="none" w="med" len="med"/>
+                      <a:tailEnd type="none" w="med" len="med"/>
+                    </a:lnL>
+                    <a:lnR w="12700" cap="flat" cmpd="sng" algn="ctr">
+                      <a:solidFill>
+                        <a:srgbClr val="4C5869"/>
+                      </a:solidFill>
+                      <a:prstDash val="solid"/>
+                      <a:round/>
+                      <a:headEnd type="none" w="med" len="med"/>
+                      <a:tailEnd type="none" w="med" len="med"/>
+                    </a:lnR>
+                    <a:lnT w="12700" cap="flat" cmpd="sng" algn="ctr">
+                      <a:solidFill>
+                        <a:srgbClr val="4C5869"/>
+                      </a:solidFill>
+                      <a:prstDash val="solid"/>
+                      <a:round/>
+                      <a:headEnd type="none" w="med" len="med"/>
+                      <a:tailEnd type="none" w="med" len="med"/>
+                    </a:lnT>
+                    <a:lnB w="12700" cap="flat" cmpd="sng" algn="ctr">
+                      <a:solidFill>
+                        <a:srgbClr val="4C5869"/>
+                      </a:solidFill>
+                      <a:prstDash val="solid"/>
+                      <a:round/>
+                      <a:headEnd type="none" w="med" len="med"/>
+                      <a:tailEnd type="none" w="med" len="med"/>
+                    </a:lnB>
+                  </a:tcPr>
+                </a:tc>
+              </a:tr>
+            </a:tbl>
+          </a:graphicData>
+        </a:graphic>
+      </p:graphicFrame>
+      <p:sp>
+        <p:nvSpPr>
+          <p:cNvPr id="6" name="Shape 3"/>
           <p:cNvSpPr/>
           <p:nvPr/>
         </p:nvSpPr>
         <p:spPr>
           <a:xfrm>
-            <a:off x="1066800" y="2250439"/>
-            <a:ext cx="2965027" cy="985520"/>
-          </a:xfrm>
-          <a:prstGeom prst="rect">
-            <a:avLst/>
-          </a:prstGeom>
-          <a:noFill/>
-          <a:ln/>
-        </p:spPr>
-        <p:txBody>
-          <a:bodyPr wrap="square" lIns="0" tIns="0" rIns="0" bIns="0" rtlCol="0" anchor="t">
-            <a:normAutofit/>
-          </a:bodyPr>
-          <a:lstStyle/>
-          <a:p>
-            <a:pPr algn="l" indent="0" marL="0">
-              <a:lnSpc>
-                <a:spcPts val="1890"/>
-              </a:lnSpc>
-              <a:buNone/>
-            </a:pPr>
-            <a:r>
-              <a:rPr lang="en-US" sz="1400" dirty="0">
-                <a:solidFill>
-                  <a:srgbClr val="F4F1EA"/>
-                </a:solidFill>
-                <a:latin typeface="Helvetica" pitchFamily="34" charset="0"/>
-                <a:ea typeface="Helvetica" pitchFamily="34" charset="-122"/>
-                <a:cs typeface="Helvetica" pitchFamily="34" charset="-120"/>
-              </a:rPr>
-              <a:t>A divisão de papéis ficou clara: a ferramenta calcula, o Auditor interpreta e o Consultor transforma o diagnóstico em ações.</a:t>
-            </a:r>
-            <a:endParaRPr lang="en-US" sz="1400" dirty="0"/>
-          </a:p>
-        </p:txBody>
-      </p:sp>
-      <p:sp>
-        <p:nvSpPr>
-          <p:cNvPr id="6" name="Shape 4"/>
-          <p:cNvSpPr/>
-          <p:nvPr/>
-        </p:nvSpPr>
-        <p:spPr>
-          <a:xfrm>
-            <a:off x="4402667" y="1620521"/>
-            <a:ext cx="3386667" cy="2324100"/>
+            <a:off x="6899593" y="1569721"/>
+            <a:ext cx="4479608" cy="1076960"/>
           </a:xfrm>
           <a:prstGeom prst="roundRect">
             <a:avLst>
-              <a:gd name="adj" fmla="val 4372"/>
+              <a:gd name="adj" fmla="val 9434"/>
             </a:avLst>
           </a:prstGeom>
           <a:solidFill>
@@ -6338,14 +7953,14 @@
       </p:sp>
       <p:sp>
         <p:nvSpPr>
-          <p:cNvPr id="7" name="Text 5"/>
+          <p:cNvPr id="7" name="Text 4"/>
           <p:cNvSpPr/>
           <p:nvPr/>
         </p:nvSpPr>
         <p:spPr>
           <a:xfrm>
-            <a:off x="4656667" y="1874521"/>
-            <a:ext cx="2965027" cy="299720"/>
+            <a:off x="7102793" y="1747521"/>
+            <a:ext cx="4195404" cy="254000"/>
           </a:xfrm>
           <a:prstGeom prst="rect">
             <a:avLst/>
@@ -6361,12 +7976,12 @@
           <a:p>
             <a:pPr algn="l" indent="0" marL="0">
               <a:lnSpc>
-                <a:spcPts val="2160"/>
-              </a:lnSpc>
-              <a:buNone/>
-            </a:pPr>
-            <a:r>
-              <a:rPr lang="en-US" sz="1800" b="1" dirty="0">
+                <a:spcPts val="1800"/>
+              </a:lnSpc>
+              <a:buNone/>
+            </a:pPr>
+            <a:r>
+              <a:rPr lang="en-US" sz="1500" b="1" dirty="0">
                 <a:solidFill>
                   <a:srgbClr val="5BA8E6"/>
                 </a:solidFill>
@@ -6374,22 +7989,22 @@
                 <a:ea typeface="Helvetica" pitchFamily="34" charset="-122"/>
                 <a:cs typeface="Helvetica" pitchFamily="34" charset="-120"/>
               </a:rPr>
-              <a:t>O que verificamos</a:t>
-            </a:r>
-            <a:endParaRPr lang="en-US" sz="1800" dirty="0"/>
-          </a:p>
-        </p:txBody>
-      </p:sp>
-      <p:sp>
-        <p:nvSpPr>
-          <p:cNvPr id="8" name="Text 6"/>
+              <a:t>Causa</a:t>
+            </a:r>
+            <a:endParaRPr lang="en-US" sz="1500" dirty="0"/>
+          </a:p>
+        </p:txBody>
+      </p:sp>
+      <p:sp>
+        <p:nvSpPr>
+          <p:cNvPr id="8" name="Text 5"/>
           <p:cNvSpPr/>
           <p:nvPr/>
         </p:nvSpPr>
         <p:spPr>
           <a:xfrm>
-            <a:off x="4656667" y="2250439"/>
-            <a:ext cx="2965027" cy="1465580"/>
+            <a:off x="7102793" y="2039621"/>
+            <a:ext cx="4195404" cy="454660"/>
           </a:xfrm>
           <a:prstGeom prst="rect">
             <a:avLst/>
@@ -6405,12 +8020,12 @@
           <a:p>
             <a:pPr algn="l" indent="0" marL="0">
               <a:lnSpc>
-                <a:spcPts val="1890"/>
-              </a:lnSpc>
-              <a:buNone/>
-            </a:pPr>
-            <a:r>
-              <a:rPr lang="en-US" sz="1400" dirty="0">
+                <a:spcPts val="1690"/>
+              </a:lnSpc>
+              <a:buNone/>
+            </a:pPr>
+            <a:r>
+              <a:rPr lang="en-US" sz="1300" dirty="0">
                 <a:solidFill>
                   <a:srgbClr val="F4F1EA"/>
                 </a:solidFill>
@@ -6418,26 +8033,26 @@
                 <a:ea typeface="Helvetica" pitchFamily="34" charset="-122"/>
                 <a:cs typeface="Helvetica" pitchFamily="34" charset="-120"/>
               </a:rPr>
-              <a:t>Os números das sugestões do Consultor não vieram da ferramenta. Ao recalculá-los, o contraste de #6A6A6A com branco é 5,41:1, e não 4,71:1 como o LLM afirmou.</a:t>
-            </a:r>
-            <a:endParaRPr lang="en-US" sz="1400" dirty="0"/>
-          </a:p>
-        </p:txBody>
-      </p:sp>
-      <p:sp>
-        <p:nvSpPr>
-          <p:cNvPr id="9" name="Shape 7"/>
+              <a:t>O Consultor só chamava o LLM e não tinha acesso à ferramenta. Ao sugerir cores, estimou o contraste.</a:t>
+            </a:r>
+            <a:endParaRPr lang="en-US" sz="1300" dirty="0"/>
+          </a:p>
+        </p:txBody>
+      </p:sp>
+      <p:sp>
+        <p:nvSpPr>
+          <p:cNvPr id="9" name="Shape 6"/>
           <p:cNvSpPr/>
           <p:nvPr/>
         </p:nvSpPr>
         <p:spPr>
           <a:xfrm>
-            <a:off x="7992533" y="1620521"/>
-            <a:ext cx="3386667" cy="2324100"/>
+            <a:off x="6899593" y="2773679"/>
+            <a:ext cx="4479608" cy="1291590"/>
           </a:xfrm>
           <a:prstGeom prst="roundRect">
             <a:avLst>
-              <a:gd name="adj" fmla="val 4372"/>
+              <a:gd name="adj" fmla="val 7866"/>
             </a:avLst>
           </a:prstGeom>
           <a:solidFill>
@@ -6448,14 +8063,14 @@
       </p:sp>
       <p:sp>
         <p:nvSpPr>
-          <p:cNvPr id="10" name="Text 8"/>
+          <p:cNvPr id="10" name="Text 7"/>
           <p:cNvSpPr/>
           <p:nvPr/>
         </p:nvSpPr>
         <p:spPr>
           <a:xfrm>
-            <a:off x="8246533" y="1874521"/>
-            <a:ext cx="2965027" cy="574040"/>
+            <a:off x="7102793" y="2951479"/>
+            <a:ext cx="4195404" cy="254000"/>
           </a:xfrm>
           <a:prstGeom prst="rect">
             <a:avLst/>
@@ -6471,35 +8086,35 @@
           <a:p>
             <a:pPr algn="l" indent="0" marL="0">
               <a:lnSpc>
-                <a:spcPts val="2160"/>
-              </a:lnSpc>
-              <a:buNone/>
-            </a:pPr>
-            <a:r>
-              <a:rPr lang="en-US" sz="1800" b="1" dirty="0">
-                <a:solidFill>
-                  <a:srgbClr val="F2B84B"/>
+                <a:spcPts val="1800"/>
+              </a:lnSpc>
+              <a:buNone/>
+            </a:pPr>
+            <a:r>
+              <a:rPr lang="en-US" sz="1500" b="1" dirty="0">
+                <a:solidFill>
+                  <a:srgbClr val="5BA8E6"/>
                 </a:solidFill>
                 <a:latin typeface="Helvetica" pitchFamily="34" charset="0"/>
                 <a:ea typeface="Helvetica" pitchFamily="34" charset="-122"/>
                 <a:cs typeface="Helvetica" pitchFamily="34" charset="-120"/>
               </a:rPr>
-              <a:t>Limites e próximos passos</a:t>
-            </a:r>
-            <a:endParaRPr lang="en-US" sz="1800" dirty="0"/>
-          </a:p>
-        </p:txBody>
-      </p:sp>
-      <p:sp>
-        <p:nvSpPr>
-          <p:cNvPr id="11" name="Text 9"/>
+              <a:t>Impacto</a:t>
+            </a:r>
+            <a:endParaRPr lang="en-US" sz="1500" dirty="0"/>
+          </a:p>
+        </p:txBody>
+      </p:sp>
+      <p:sp>
+        <p:nvSpPr>
+          <p:cNvPr id="11" name="Text 8"/>
           <p:cNvSpPr/>
           <p:nvPr/>
         </p:nvSpPr>
         <p:spPr>
           <a:xfrm>
-            <a:off x="8246533" y="2524761"/>
-            <a:ext cx="2965027" cy="985520"/>
+            <a:off x="7102793" y="3243579"/>
+            <a:ext cx="4195404" cy="669290"/>
           </a:xfrm>
           <a:prstGeom prst="rect">
             <a:avLst/>
@@ -6515,12 +8130,12 @@
           <a:p>
             <a:pPr algn="l" indent="0" marL="0">
               <a:lnSpc>
-                <a:spcPts val="1890"/>
-              </a:lnSpc>
-              <a:buNone/>
-            </a:pPr>
-            <a:r>
-              <a:rPr lang="en-US" sz="1400" dirty="0">
+                <a:spcPts val="1690"/>
+              </a:lnSpc>
+              <a:buNone/>
+            </a:pPr>
+            <a:r>
+              <a:rPr lang="en-US" sz="1300" dirty="0">
                 <a:solidFill>
                   <a:srgbClr val="F4F1EA"/>
                 </a:solidFill>
@@ -6528,9 +8143,9 @@
                 <a:ea typeface="Helvetica" pitchFamily="34" charset="-122"/>
                 <a:cs typeface="Helvetica" pitchFamily="34" charset="-120"/>
               </a:rPr>
-              <a:t>Avalia só o contraste de texto, não toda a WCAG. Próximo passo: o Consultor chamar a ferramenta para validar cada cor sugerida.</a:t>
-            </a:r>
-            <a:endParaRPr lang="en-US" sz="1400" dirty="0"/>
+              <a:t>Números com aparência precisa, mas incorretos. A colaboração entre os agentes não garantia a verificação.</a:t>
+            </a:r>
+            <a:endParaRPr lang="en-US" sz="1300" dirty="0"/>
           </a:p>
         </p:txBody>
       </p:sp>
@@ -6548,7 +8163,7 @@
     <p:bg>
       <p:bgPr>
         <a:solidFill>
-          <a:srgbClr val="F2B84B"/>
+          <a:srgbClr val="F4F1EA"/>
         </a:solidFill>
       </p:bgPr>
     </p:bg>
@@ -6576,8 +8191,8 @@
         </p:nvSpPr>
         <p:spPr>
           <a:xfrm>
-            <a:off x="812800" y="2451100"/>
-            <a:ext cx="10883392" cy="640080"/>
+            <a:off x="812800" y="812800"/>
+            <a:ext cx="10883392" cy="528320"/>
           </a:xfrm>
           <a:prstGeom prst="rect">
             <a:avLst/>
@@ -6593,12 +8208,12 @@
           <a:p>
             <a:pPr algn="l" indent="0" marL="0">
               <a:lnSpc>
-                <a:spcPts val="4840"/>
-              </a:lnSpc>
-              <a:buNone/>
-            </a:pPr>
-            <a:r>
-              <a:rPr lang="en-US" sz="4400" b="1" i="0" dirty="0">
+                <a:spcPts val="3960"/>
+              </a:lnSpc>
+              <a:buNone/>
+            </a:pPr>
+            <a:r>
+              <a:rPr lang="en-US" sz="3600" b="1" i="0" dirty="0">
                 <a:solidFill>
                   <a:srgbClr val="0F1B2D"/>
                 </a:solidFill>
@@ -6606,9 +8221,9 @@
                 <a:ea typeface="Helvetica" pitchFamily="34" charset="-122"/>
                 <a:cs typeface="Helvetica" pitchFamily="34" charset="-120"/>
               </a:rPr>
-              <a:t>Vídeo de apresentação</a:t>
-            </a:r>
-            <a:endParaRPr lang="en-US" sz="4400" dirty="0"/>
+              <a:t>Melhoria: nó verificador</a:t>
+            </a:r>
+            <a:endParaRPr lang="en-US" sz="3600" dirty="0"/>
           </a:p>
         </p:txBody>
       </p:sp>
@@ -6620,8 +8235,302 @@
         </p:nvSpPr>
         <p:spPr>
           <a:xfrm>
-            <a:off x="812800" y="3319779"/>
-            <a:ext cx="10883392" cy="388620"/>
+            <a:off x="812800" y="1569721"/>
+            <a:ext cx="5983076" cy="2546350"/>
+          </a:xfrm>
+          <a:prstGeom prst="roundRect">
+            <a:avLst>
+              <a:gd name="adj" fmla="val 3990"/>
+            </a:avLst>
+          </a:prstGeom>
+          <a:solidFill>
+            <a:srgbClr val="0F1B2D"/>
+          </a:solidFill>
+          <a:ln/>
+        </p:spPr>
+        <p:txBody>
+          <a:bodyPr wrap="square" lIns="224242" tIns="198842" rIns="59990" bIns="198842" rtlCol="0" anchor="t">
+            <a:normAutofit/>
+          </a:bodyPr>
+          <a:lstStyle/>
+          <a:p>
+            <a:pPr algn="l" indent="0" marL="0">
+              <a:lnSpc>
+                <a:spcPts val="1860"/>
+              </a:lnSpc>
+              <a:buNone/>
+            </a:pPr>
+            <a:r>
+              <a:rPr lang="en-US" sz="1200" dirty="0">
+                <a:solidFill>
+                  <a:srgbClr val="F2B84B"/>
+                </a:solidFill>
+                <a:latin typeface="Courier New" pitchFamily="49" charset="0"/>
+                <a:ea typeface="Courier New" pitchFamily="49" charset="-122"/>
+                <a:cs typeface="Courier New" pitchFamily="49" charset="-120"/>
+              </a:rPr>
+              <a:t>def no_verificador</a:t>
+            </a:r>
+            <a:r>
+              <a:rPr lang="en-US" sz="1200" dirty="0">
+                <a:solidFill>
+                  <a:srgbClr val="F4F1EA"/>
+                </a:solidFill>
+                <a:latin typeface="Courier New" pitchFamily="49" charset="0"/>
+                <a:ea typeface="Courier New" pitchFamily="49" charset="-122"/>
+                <a:cs typeface="Courier New" pitchFamily="49" charset="-120"/>
+              </a:rPr>
+              <a:t>(estado):</a:t>
+            </a:r>
+            <a:endParaRPr lang="en-US" sz="1200" dirty="0"/>
+          </a:p>
+          <a:p>
+            <a:pPr algn="l" indent="0" marL="0">
+              <a:lnSpc>
+                <a:spcPts val="1860"/>
+              </a:lnSpc>
+              <a:buNone/>
+            </a:pPr>
+            <a:r>
+              <a:rPr lang="en-US" sz="1200" dirty="0">
+                <a:solidFill>
+                  <a:srgbClr val="F4F1EA"/>
+                </a:solidFill>
+                <a:latin typeface="Courier New" pitchFamily="49" charset="0"/>
+                <a:ea typeface="Courier New" pitchFamily="49" charset="-122"/>
+                <a:cs typeface="Courier New" pitchFamily="49" charset="-120"/>
+              </a:rPr>
+              <a:t>    pares = PADRAO_SUGESTAO.findall(</a:t>
+            </a:r>
+            <a:endParaRPr lang="en-US" sz="1200" dirty="0"/>
+          </a:p>
+          <a:p>
+            <a:pPr algn="l" indent="0" marL="0">
+              <a:lnSpc>
+                <a:spcPts val="1860"/>
+              </a:lnSpc>
+              <a:buNone/>
+            </a:pPr>
+            <a:r>
+              <a:rPr lang="en-US" sz="1200" dirty="0">
+                <a:solidFill>
+                  <a:srgbClr val="F4F1EA"/>
+                </a:solidFill>
+                <a:latin typeface="Courier New" pitchFamily="49" charset="0"/>
+                <a:ea typeface="Courier New" pitchFamily="49" charset="-122"/>
+                <a:cs typeface="Courier New" pitchFamily="49" charset="-120"/>
+              </a:rPr>
+              <a:t>        estado[</a:t>
+            </a:r>
+            <a:r>
+              <a:rPr lang="en-US" sz="1200" dirty="0">
+                <a:solidFill>
+                  <a:srgbClr val="5BA8E6"/>
+                </a:solidFill>
+                <a:latin typeface="Courier New" pitchFamily="49" charset="0"/>
+                <a:ea typeface="Courier New" pitchFamily="49" charset="-122"/>
+                <a:cs typeface="Courier New" pitchFamily="49" charset="-120"/>
+              </a:rPr>
+              <a:t>"recomendacao_consultor"</a:t>
+            </a:r>
+            <a:r>
+              <a:rPr lang="en-US" sz="1200" dirty="0">
+                <a:solidFill>
+                  <a:srgbClr val="F4F1EA"/>
+                </a:solidFill>
+                <a:latin typeface="Courier New" pitchFamily="49" charset="0"/>
+                <a:ea typeface="Courier New" pitchFamily="49" charset="-122"/>
+                <a:cs typeface="Courier New" pitchFamily="49" charset="-120"/>
+              </a:rPr>
+              <a:t>])</a:t>
+            </a:r>
+            <a:endParaRPr lang="en-US" sz="1200" dirty="0"/>
+          </a:p>
+          <a:p>
+            <a:pPr algn="l" indent="0" marL="0">
+              <a:lnSpc>
+                <a:spcPts val="1860"/>
+              </a:lnSpc>
+              <a:buNone/>
+            </a:pPr>
+            <a:r>
+              <a:rPr lang="en-US" sz="1200" dirty="0">
+                <a:solidFill>
+                  <a:srgbClr val="F4F1EA"/>
+                </a:solidFill>
+                <a:latin typeface="Courier New" pitchFamily="49" charset="0"/>
+                <a:ea typeface="Courier New" pitchFamily="49" charset="-122"/>
+                <a:cs typeface="Courier New" pitchFamily="49" charset="-120"/>
+              </a:rPr>
+              <a:t>    verificacoes = [avaliar_contraste.invoke(</a:t>
+            </a:r>
+            <a:endParaRPr lang="en-US" sz="1200" dirty="0"/>
+          </a:p>
+          <a:p>
+            <a:pPr algn="l" indent="0" marL="0">
+              <a:lnSpc>
+                <a:spcPts val="1860"/>
+              </a:lnSpc>
+              <a:buNone/>
+            </a:pPr>
+            <a:r>
+              <a:rPr lang="en-US" sz="1200" dirty="0">
+                <a:solidFill>
+                  <a:srgbClr val="F4F1EA"/>
+                </a:solidFill>
+                <a:latin typeface="Courier New" pitchFamily="49" charset="0"/>
+                <a:ea typeface="Courier New" pitchFamily="49" charset="-122"/>
+                <a:cs typeface="Courier New" pitchFamily="49" charset="-120"/>
+              </a:rPr>
+              <a:t>        {</a:t>
+            </a:r>
+            <a:r>
+              <a:rPr lang="en-US" sz="1200" dirty="0">
+                <a:solidFill>
+                  <a:srgbClr val="5BA8E6"/>
+                </a:solidFill>
+                <a:latin typeface="Courier New" pitchFamily="49" charset="0"/>
+                <a:ea typeface="Courier New" pitchFamily="49" charset="-122"/>
+                <a:cs typeface="Courier New" pitchFamily="49" charset="-120"/>
+              </a:rPr>
+              <a:t>"texto_hex"</a:t>
+            </a:r>
+            <a:r>
+              <a:rPr lang="en-US" sz="1200" dirty="0">
+                <a:solidFill>
+                  <a:srgbClr val="F4F1EA"/>
+                </a:solidFill>
+                <a:latin typeface="Courier New" pitchFamily="49" charset="0"/>
+                <a:ea typeface="Courier New" pitchFamily="49" charset="-122"/>
+                <a:cs typeface="Courier New" pitchFamily="49" charset="-120"/>
+              </a:rPr>
+              <a:t>: t, </a:t>
+            </a:r>
+            <a:r>
+              <a:rPr lang="en-US" sz="1200" dirty="0">
+                <a:solidFill>
+                  <a:srgbClr val="5BA8E6"/>
+                </a:solidFill>
+                <a:latin typeface="Courier New" pitchFamily="49" charset="0"/>
+                <a:ea typeface="Courier New" pitchFamily="49" charset="-122"/>
+                <a:cs typeface="Courier New" pitchFamily="49" charset="-120"/>
+              </a:rPr>
+              <a:t>"fundo_hex"</a:t>
+            </a:r>
+            <a:r>
+              <a:rPr lang="en-US" sz="1200" dirty="0">
+                <a:solidFill>
+                  <a:srgbClr val="F4F1EA"/>
+                </a:solidFill>
+                <a:latin typeface="Courier New" pitchFamily="49" charset="0"/>
+                <a:ea typeface="Courier New" pitchFamily="49" charset="-122"/>
+                <a:cs typeface="Courier New" pitchFamily="49" charset="-120"/>
+              </a:rPr>
+              <a:t>: f})</a:t>
+            </a:r>
+            <a:endParaRPr lang="en-US" sz="1200" dirty="0"/>
+          </a:p>
+          <a:p>
+            <a:pPr algn="l" indent="0" marL="0">
+              <a:lnSpc>
+                <a:spcPts val="1860"/>
+              </a:lnSpc>
+              <a:buNone/>
+            </a:pPr>
+            <a:r>
+              <a:rPr lang="en-US" sz="1200" dirty="0">
+                <a:solidFill>
+                  <a:srgbClr val="F4F1EA"/>
+                </a:solidFill>
+                <a:latin typeface="Courier New" pitchFamily="49" charset="0"/>
+                <a:ea typeface="Courier New" pitchFamily="49" charset="-122"/>
+                <a:cs typeface="Courier New" pitchFamily="49" charset="-120"/>
+              </a:rPr>
+              <a:t>        for t, f in dict.fromkeys(pares)]</a:t>
+            </a:r>
+            <a:endParaRPr lang="en-US" sz="1200" dirty="0"/>
+          </a:p>
+          <a:p>
+            <a:pPr algn="l" indent="0" marL="0">
+              <a:lnSpc>
+                <a:spcPts val="1860"/>
+              </a:lnSpc>
+              <a:buNone/>
+            </a:pPr>
+            <a:r>
+              <a:rPr lang="en-US" sz="1200" dirty="0">
+                <a:solidFill>
+                  <a:srgbClr val="F4F1EA"/>
+                </a:solidFill>
+                <a:latin typeface="Courier New" pitchFamily="49" charset="0"/>
+                <a:ea typeface="Courier New" pitchFamily="49" charset="-122"/>
+                <a:cs typeface="Courier New" pitchFamily="49" charset="-120"/>
+              </a:rPr>
+              <a:t>    return {</a:t>
+            </a:r>
+            <a:r>
+              <a:rPr lang="en-US" sz="1200" dirty="0">
+                <a:solidFill>
+                  <a:srgbClr val="5BA8E6"/>
+                </a:solidFill>
+                <a:latin typeface="Courier New" pitchFamily="49" charset="0"/>
+                <a:ea typeface="Courier New" pitchFamily="49" charset="-122"/>
+                <a:cs typeface="Courier New" pitchFamily="49" charset="-120"/>
+              </a:rPr>
+              <a:t>"verificacao_sugestoes"</a:t>
+            </a:r>
+            <a:r>
+              <a:rPr lang="en-US" sz="1200" dirty="0">
+                <a:solidFill>
+                  <a:srgbClr val="F4F1EA"/>
+                </a:solidFill>
+                <a:latin typeface="Courier New" pitchFamily="49" charset="0"/>
+                <a:ea typeface="Courier New" pitchFamily="49" charset="-122"/>
+                <a:cs typeface="Courier New" pitchFamily="49" charset="-120"/>
+              </a:rPr>
+              <a:t>: verificacoes}</a:t>
+            </a:r>
+            <a:endParaRPr lang="en-US" sz="1200" dirty="0"/>
+          </a:p>
+        </p:txBody>
+      </p:sp>
+      <p:sp>
+        <p:nvSpPr>
+          <p:cNvPr id="4" name="Shape 2"/>
+          <p:cNvSpPr/>
+          <p:nvPr/>
+        </p:nvSpPr>
+        <p:spPr>
+          <a:xfrm>
+            <a:off x="7005426" y="1576071"/>
+            <a:ext cx="4367424" cy="1304290"/>
+          </a:xfrm>
+          <a:prstGeom prst="roundRect">
+            <a:avLst>
+              <a:gd name="adj" fmla="val 7303"/>
+            </a:avLst>
+          </a:prstGeom>
+          <a:solidFill>
+            <a:srgbClr val="FFFFFF"/>
+          </a:solidFill>
+          <a:ln w="12700">
+            <a:solidFill>
+              <a:srgbClr val="0F1B2D"/>
+            </a:solidFill>
+            <a:prstDash val="solid"/>
+          </a:ln>
+        </p:spPr>
+      </p:sp>
+      <p:sp>
+        <p:nvSpPr>
+          <p:cNvPr id="5" name="Text 3"/>
+          <p:cNvSpPr/>
+          <p:nvPr/>
+        </p:nvSpPr>
+        <p:spPr>
+          <a:xfrm>
+            <a:off x="7214976" y="1760221"/>
+            <a:ext cx="4066774" cy="254000"/>
           </a:xfrm>
           <a:prstGeom prst="rect">
             <a:avLst/>
@@ -6637,35 +8546,35 @@
           <a:p>
             <a:pPr algn="l" indent="0" marL="0">
               <a:lnSpc>
-                <a:spcPts val="2860"/>
-              </a:lnSpc>
-              <a:buNone/>
-            </a:pPr>
-            <a:r>
-              <a:rPr lang="en-US" sz="2200" dirty="0">
-                <a:solidFill>
-                  <a:srgbClr val="0F1B2D"/>
+                <a:spcPts val="1800"/>
+              </a:lnSpc>
+              <a:buNone/>
+            </a:pPr>
+            <a:r>
+              <a:rPr lang="en-US" sz="1500" b="1" dirty="0">
+                <a:solidFill>
+                  <a:srgbClr val="1F5FA8"/>
                 </a:solidFill>
                 <a:latin typeface="Helvetica" pitchFamily="34" charset="0"/>
                 <a:ea typeface="Helvetica" pitchFamily="34" charset="-122"/>
                 <a:cs typeface="Helvetica" pitchFamily="34" charset="-120"/>
               </a:rPr>
-              <a:t>[colar aqui o link do vídeo]</a:t>
-            </a:r>
-            <a:endParaRPr lang="en-US" sz="2200" dirty="0"/>
-          </a:p>
-        </p:txBody>
-      </p:sp>
-      <p:sp>
-        <p:nvSpPr>
-          <p:cNvPr id="4" name="Text 2"/>
+              <a:t>O que mudou</a:t>
+            </a:r>
+            <a:endParaRPr lang="en-US" sz="1500" dirty="0"/>
+          </a:p>
+        </p:txBody>
+      </p:sp>
+      <p:sp>
+        <p:nvSpPr>
+          <p:cNvPr id="6" name="Text 4"/>
           <p:cNvSpPr/>
           <p:nvPr/>
         </p:nvSpPr>
         <p:spPr>
           <a:xfrm>
-            <a:off x="812800" y="3937000"/>
-            <a:ext cx="10883392" cy="292100"/>
+            <a:off x="7214976" y="2052321"/>
+            <a:ext cx="4066774" cy="669290"/>
           </a:xfrm>
           <a:prstGeom prst="rect">
             <a:avLst/>
@@ -6681,12 +8590,12 @@
           <a:p>
             <a:pPr algn="l" indent="0" marL="0">
               <a:lnSpc>
-                <a:spcPts val="2100"/>
-              </a:lnSpc>
-              <a:buNone/>
-            </a:pPr>
-            <a:r>
-              <a:rPr lang="en-US" sz="1500" dirty="0">
+                <a:spcPts val="1690"/>
+              </a:lnSpc>
+              <a:buNone/>
+            </a:pPr>
+            <a:r>
+              <a:rPr lang="en-US" sz="1300" dirty="0">
                 <a:solidFill>
                   <a:srgbClr val="0F1B2D"/>
                 </a:solidFill>
@@ -6694,9 +8603,647 @@
                 <a:ea typeface="Helvetica" pitchFamily="34" charset="-122"/>
                 <a:cs typeface="Helvetica" pitchFamily="34" charset="-120"/>
               </a:rPr>
-              <a:t>Anderson Fernandes Barbosa · João Pedro Brites</a:t>
+              <a:t>O Consultor passa a sugerir cores em linhas SUGESTAO: texto=#… fundo=#…, sem informar contraste.</a:t>
+            </a:r>
+            <a:endParaRPr lang="en-US" sz="1300" dirty="0"/>
+          </a:p>
+        </p:txBody>
+      </p:sp>
+      <p:sp>
+        <p:nvSpPr>
+          <p:cNvPr id="7" name="Shape 5"/>
+          <p:cNvSpPr/>
+          <p:nvPr/>
+        </p:nvSpPr>
+        <p:spPr>
+          <a:xfrm>
+            <a:off x="7005426" y="3020061"/>
+            <a:ext cx="4367424" cy="1089660"/>
+          </a:xfrm>
+          <a:prstGeom prst="roundRect">
+            <a:avLst>
+              <a:gd name="adj" fmla="val 8741"/>
+            </a:avLst>
+          </a:prstGeom>
+          <a:solidFill>
+            <a:srgbClr val="FFFFFF"/>
+          </a:solidFill>
+          <a:ln w="12700">
+            <a:solidFill>
+              <a:srgbClr val="0F1B2D"/>
+            </a:solidFill>
+            <a:prstDash val="solid"/>
+          </a:ln>
+        </p:spPr>
+      </p:sp>
+      <p:sp>
+        <p:nvSpPr>
+          <p:cNvPr id="8" name="Text 6"/>
+          <p:cNvSpPr/>
+          <p:nvPr/>
+        </p:nvSpPr>
+        <p:spPr>
+          <a:xfrm>
+            <a:off x="7214976" y="3204211"/>
+            <a:ext cx="4066774" cy="254000"/>
+          </a:xfrm>
+          <a:prstGeom prst="rect">
+            <a:avLst/>
+          </a:prstGeom>
+          <a:noFill/>
+          <a:ln/>
+        </p:spPr>
+        <p:txBody>
+          <a:bodyPr wrap="square" lIns="0" tIns="0" rIns="0" bIns="0" rtlCol="0" anchor="t">
+            <a:normAutofit/>
+          </a:bodyPr>
+          <a:lstStyle/>
+          <a:p>
+            <a:pPr algn="l" indent="0" marL="0">
+              <a:lnSpc>
+                <a:spcPts val="1800"/>
+              </a:lnSpc>
+              <a:buNone/>
+            </a:pPr>
+            <a:r>
+              <a:rPr lang="en-US" sz="1500" b="1" dirty="0">
+                <a:solidFill>
+                  <a:srgbClr val="1F5FA8"/>
+                </a:solidFill>
+                <a:latin typeface="Helvetica" pitchFamily="34" charset="0"/>
+                <a:ea typeface="Helvetica" pitchFamily="34" charset="-122"/>
+                <a:cs typeface="Helvetica" pitchFamily="34" charset="-120"/>
+              </a:rPr>
+              <a:t>Como funciona</a:t>
             </a:r>
             <a:endParaRPr lang="en-US" sz="1500" dirty="0"/>
+          </a:p>
+        </p:txBody>
+      </p:sp>
+      <p:sp>
+        <p:nvSpPr>
+          <p:cNvPr id="9" name="Text 7"/>
+          <p:cNvSpPr/>
+          <p:nvPr/>
+        </p:nvSpPr>
+        <p:spPr>
+          <a:xfrm>
+            <a:off x="7214976" y="3496311"/>
+            <a:ext cx="4066774" cy="454660"/>
+          </a:xfrm>
+          <a:prstGeom prst="rect">
+            <a:avLst/>
+          </a:prstGeom>
+          <a:noFill/>
+          <a:ln/>
+        </p:spPr>
+        <p:txBody>
+          <a:bodyPr wrap="square" lIns="0" tIns="0" rIns="0" bIns="0" rtlCol="0" anchor="t">
+            <a:normAutofit/>
+          </a:bodyPr>
+          <a:lstStyle/>
+          <a:p>
+            <a:pPr algn="l" indent="0" marL="0">
+              <a:lnSpc>
+                <a:spcPts val="1690"/>
+              </a:lnSpc>
+              <a:buNone/>
+            </a:pPr>
+            <a:r>
+              <a:rPr lang="en-US" sz="1300" dirty="0">
+                <a:solidFill>
+                  <a:srgbClr val="0F1B2D"/>
+                </a:solidFill>
+                <a:latin typeface="Helvetica" pitchFamily="34" charset="0"/>
+                <a:ea typeface="Helvetica" pitchFamily="34" charset="-122"/>
+                <a:cs typeface="Helvetica" pitchFamily="34" charset="-120"/>
+              </a:rPr>
+              <a:t>O verificador extrai os pares com regex e chama avaliar_contraste para cada um.</a:t>
+            </a:r>
+            <a:endParaRPr lang="en-US" sz="1300" dirty="0"/>
+          </a:p>
+        </p:txBody>
+      </p:sp>
+      <p:sp>
+        <p:nvSpPr>
+          <p:cNvPr id="10" name="Shape 8"/>
+          <p:cNvSpPr/>
+          <p:nvPr/>
+        </p:nvSpPr>
+        <p:spPr>
+          <a:xfrm>
+            <a:off x="819150" y="4376421"/>
+            <a:ext cx="10553700" cy="1089660"/>
+          </a:xfrm>
+          <a:prstGeom prst="roundRect">
+            <a:avLst>
+              <a:gd name="adj" fmla="val 8741"/>
+            </a:avLst>
+          </a:prstGeom>
+          <a:solidFill>
+            <a:srgbClr val="FFFFFF"/>
+          </a:solidFill>
+          <a:ln w="12700">
+            <a:solidFill>
+              <a:srgbClr val="0F1B2D"/>
+            </a:solidFill>
+            <a:prstDash val="solid"/>
+          </a:ln>
+        </p:spPr>
+      </p:sp>
+      <p:sp>
+        <p:nvSpPr>
+          <p:cNvPr id="11" name="Text 9"/>
+          <p:cNvSpPr/>
+          <p:nvPr/>
+        </p:nvSpPr>
+        <p:spPr>
+          <a:xfrm>
+            <a:off x="1028700" y="4560571"/>
+            <a:ext cx="10438638" cy="254000"/>
+          </a:xfrm>
+          <a:prstGeom prst="rect">
+            <a:avLst/>
+          </a:prstGeom>
+          <a:noFill/>
+          <a:ln/>
+        </p:spPr>
+        <p:txBody>
+          <a:bodyPr wrap="square" lIns="0" tIns="0" rIns="0" bIns="0" rtlCol="0" anchor="t">
+            <a:normAutofit/>
+          </a:bodyPr>
+          <a:lstStyle/>
+          <a:p>
+            <a:pPr algn="l" indent="0" marL="0">
+              <a:lnSpc>
+                <a:spcPts val="1800"/>
+              </a:lnSpc>
+              <a:buNone/>
+            </a:pPr>
+            <a:r>
+              <a:rPr lang="en-US" sz="1500" b="1" dirty="0">
+                <a:solidFill>
+                  <a:srgbClr val="1F5FA8"/>
+                </a:solidFill>
+                <a:latin typeface="Helvetica" pitchFamily="34" charset="0"/>
+                <a:ea typeface="Helvetica" pitchFamily="34" charset="-122"/>
+                <a:cs typeface="Helvetica" pitchFamily="34" charset="-120"/>
+              </a:rPr>
+              <a:t>Conceitos de agentes aplicados</a:t>
+            </a:r>
+            <a:endParaRPr lang="en-US" sz="1500" dirty="0"/>
+          </a:p>
+        </p:txBody>
+      </p:sp>
+      <p:sp>
+        <p:nvSpPr>
+          <p:cNvPr id="12" name="Text 10"/>
+          <p:cNvSpPr/>
+          <p:nvPr/>
+        </p:nvSpPr>
+        <p:spPr>
+          <a:xfrm>
+            <a:off x="1028700" y="4852671"/>
+            <a:ext cx="10438638" cy="454660"/>
+          </a:xfrm>
+          <a:prstGeom prst="rect">
+            <a:avLst/>
+          </a:prstGeom>
+          <a:noFill/>
+          <a:ln/>
+        </p:spPr>
+        <p:txBody>
+          <a:bodyPr wrap="square" lIns="0" tIns="0" rIns="0" bIns="0" rtlCol="0" anchor="t">
+            <a:normAutofit/>
+          </a:bodyPr>
+          <a:lstStyle/>
+          <a:p>
+            <a:pPr algn="l" indent="0" marL="0">
+              <a:lnSpc>
+                <a:spcPts val="1690"/>
+              </a:lnSpc>
+              <a:buNone/>
+            </a:pPr>
+            <a:r>
+              <a:rPr lang="en-US" sz="1300" dirty="0">
+                <a:solidFill>
+                  <a:srgbClr val="0F1B2D"/>
+                </a:solidFill>
+                <a:latin typeface="Helvetica" pitchFamily="34" charset="0"/>
+                <a:ea typeface="Helvetica" pitchFamily="34" charset="-122"/>
+                <a:cs typeface="Helvetica" pitchFamily="34" charset="-120"/>
+              </a:rPr>
+              <a:t>A ferramenta é a fonte de verdade e o LLM interpreta e sugere. Cada etapa tem um papel definido, e o estado compartilhado liga as etapas. As saídas do LLM passam por verificação.</a:t>
+            </a:r>
+            <a:endParaRPr lang="en-US" sz="1300" dirty="0"/>
+          </a:p>
+        </p:txBody>
+      </p:sp>
+    </p:spTree>
+  </p:cSld>
+  <p:clrMapOvr>
+    <a:masterClrMapping/>
+  </p:clrMapOvr>
+</p:sld>
+</file>
+
+<file path=ppt/slides/slide9.xml><?xml version="1.0" encoding="utf-8"?>
+<p:sld xmlns:a="http://schemas.openxmlformats.org/drawingml/2006/main" xmlns:r="http://schemas.openxmlformats.org/officeDocument/2006/relationships" xmlns:p="http://schemas.openxmlformats.org/presentationml/2006/main">
+  <p:cSld name="Slide 9">
+    <p:bg>
+      <p:bgPr>
+        <a:solidFill>
+          <a:srgbClr val="0F1B2D"/>
+        </a:solidFill>
+      </p:bgPr>
+    </p:bg>
+    <p:spTree>
+      <p:nvGrpSpPr>
+        <p:cNvPr id="1" name=""/>
+        <p:cNvGrpSpPr/>
+        <p:nvPr/>
+      </p:nvGrpSpPr>
+      <p:grpSpPr>
+        <a:xfrm>
+          <a:off x="0" y="0"/>
+          <a:ext cx="0" cy="0"/>
+          <a:chOff x="0" y="0"/>
+          <a:chExt cx="0" cy="0"/>
+        </a:xfrm>
+      </p:grpSpPr>
+      <p:sp>
+        <p:nvSpPr>
+          <p:cNvPr id="2" name="Text 0"/>
+          <p:cNvSpPr/>
+          <p:nvPr>
+            <p:ph type="title"/>
+          </p:nvPr>
+        </p:nvSpPr>
+        <p:spPr>
+          <a:xfrm>
+            <a:off x="812800" y="812800"/>
+            <a:ext cx="10883392" cy="528320"/>
+          </a:xfrm>
+          <a:prstGeom prst="rect">
+            <a:avLst/>
+          </a:prstGeom>
+          <a:noFill/>
+          <a:ln/>
+        </p:spPr>
+        <p:txBody>
+          <a:bodyPr wrap="square" lIns="0" tIns="0" rIns="0" bIns="0" rtlCol="0" anchor="t">
+            <a:normAutofit/>
+          </a:bodyPr>
+          <a:lstStyle/>
+          <a:p>
+            <a:pPr algn="l" indent="0" marL="0">
+              <a:lnSpc>
+                <a:spcPts val="3960"/>
+              </a:lnSpc>
+              <a:buNone/>
+            </a:pPr>
+            <a:r>
+              <a:rPr lang="en-US" sz="3600" b="1" i="0" dirty="0">
+                <a:solidFill>
+                  <a:srgbClr val="F4F1EA"/>
+                </a:solidFill>
+                <a:latin typeface="Helvetica" pitchFamily="34" charset="0"/>
+                <a:ea typeface="Helvetica" pitchFamily="34" charset="-122"/>
+                <a:cs typeface="Helvetica" pitchFamily="34" charset="-120"/>
+              </a:rPr>
+              <a:t>Conclusões</a:t>
+            </a:r>
+            <a:endParaRPr lang="en-US" sz="3600" dirty="0"/>
+          </a:p>
+        </p:txBody>
+      </p:sp>
+      <p:sp>
+        <p:nvSpPr>
+          <p:cNvPr id="3" name="Shape 1"/>
+          <p:cNvSpPr/>
+          <p:nvPr/>
+        </p:nvSpPr>
+        <p:spPr>
+          <a:xfrm>
+            <a:off x="812800" y="1620521"/>
+            <a:ext cx="3386667" cy="2358390"/>
+          </a:xfrm>
+          <a:prstGeom prst="roundRect">
+            <a:avLst>
+              <a:gd name="adj" fmla="val 4308"/>
+            </a:avLst>
+          </a:prstGeom>
+          <a:solidFill>
+            <a:srgbClr val="1B2A41"/>
+          </a:solidFill>
+          <a:ln/>
+        </p:spPr>
+      </p:sp>
+      <p:sp>
+        <p:nvSpPr>
+          <p:cNvPr id="4" name="Text 2"/>
+          <p:cNvSpPr/>
+          <p:nvPr/>
+        </p:nvSpPr>
+        <p:spPr>
+          <a:xfrm>
+            <a:off x="1066800" y="1874521"/>
+            <a:ext cx="2965027" cy="299720"/>
+          </a:xfrm>
+          <a:prstGeom prst="rect">
+            <a:avLst/>
+          </a:prstGeom>
+          <a:noFill/>
+          <a:ln/>
+        </p:spPr>
+        <p:txBody>
+          <a:bodyPr wrap="square" lIns="0" tIns="0" rIns="0" bIns="0" rtlCol="0" anchor="t">
+            <a:normAutofit/>
+          </a:bodyPr>
+          <a:lstStyle/>
+          <a:p>
+            <a:pPr algn="l" indent="0" marL="0">
+              <a:lnSpc>
+                <a:spcPts val="2160"/>
+              </a:lnSpc>
+              <a:buNone/>
+            </a:pPr>
+            <a:r>
+              <a:rPr lang="en-US" sz="1800" b="1" dirty="0">
+                <a:solidFill>
+                  <a:srgbClr val="F2B84B"/>
+                </a:solidFill>
+                <a:latin typeface="Helvetica" pitchFamily="34" charset="0"/>
+                <a:ea typeface="Helvetica" pitchFamily="34" charset="-122"/>
+                <a:cs typeface="Helvetica" pitchFamily="34" charset="-120"/>
+              </a:rPr>
+              <a:t>O que funcionou</a:t>
+            </a:r>
+            <a:endParaRPr lang="en-US" sz="1800" dirty="0"/>
+          </a:p>
+        </p:txBody>
+      </p:sp>
+      <p:sp>
+        <p:nvSpPr>
+          <p:cNvPr id="5" name="Text 3"/>
+          <p:cNvSpPr/>
+          <p:nvPr/>
+        </p:nvSpPr>
+        <p:spPr>
+          <a:xfrm>
+            <a:off x="1066800" y="2250442"/>
+            <a:ext cx="2965027" cy="985520"/>
+          </a:xfrm>
+          <a:prstGeom prst="rect">
+            <a:avLst/>
+          </a:prstGeom>
+          <a:noFill/>
+          <a:ln/>
+        </p:spPr>
+        <p:txBody>
+          <a:bodyPr wrap="square" lIns="0" tIns="0" rIns="0" bIns="0" rtlCol="0" anchor="t">
+            <a:normAutofit/>
+          </a:bodyPr>
+          <a:lstStyle/>
+          <a:p>
+            <a:pPr algn="l" indent="0" marL="0">
+              <a:lnSpc>
+                <a:spcPts val="1890"/>
+              </a:lnSpc>
+              <a:buNone/>
+            </a:pPr>
+            <a:r>
+              <a:rPr lang="en-US" sz="1400" dirty="0">
+                <a:solidFill>
+                  <a:srgbClr val="F4F1EA"/>
+                </a:solidFill>
+                <a:latin typeface="Helvetica" pitchFamily="34" charset="0"/>
+                <a:ea typeface="Helvetica" pitchFamily="34" charset="-122"/>
+                <a:cs typeface="Helvetica" pitchFamily="34" charset="-120"/>
+              </a:rPr>
+              <a:t>A divisão de papéis ficou clara: a ferramenta calcula, o Auditor interpreta e o Consultor transforma o diagnóstico em ações.</a:t>
+            </a:r>
+            <a:endParaRPr lang="en-US" sz="1400" dirty="0"/>
+          </a:p>
+        </p:txBody>
+      </p:sp>
+      <p:sp>
+        <p:nvSpPr>
+          <p:cNvPr id="6" name="Shape 4"/>
+          <p:cNvSpPr/>
+          <p:nvPr/>
+        </p:nvSpPr>
+        <p:spPr>
+          <a:xfrm>
+            <a:off x="4402667" y="1620521"/>
+            <a:ext cx="3386667" cy="2358390"/>
+          </a:xfrm>
+          <a:prstGeom prst="roundRect">
+            <a:avLst>
+              <a:gd name="adj" fmla="val 4308"/>
+            </a:avLst>
+          </a:prstGeom>
+          <a:solidFill>
+            <a:srgbClr val="1B2A41"/>
+          </a:solidFill>
+          <a:ln/>
+        </p:spPr>
+      </p:sp>
+      <p:sp>
+        <p:nvSpPr>
+          <p:cNvPr id="7" name="Text 5"/>
+          <p:cNvSpPr/>
+          <p:nvPr/>
+        </p:nvSpPr>
+        <p:spPr>
+          <a:xfrm>
+            <a:off x="4656667" y="1874521"/>
+            <a:ext cx="2965027" cy="299720"/>
+          </a:xfrm>
+          <a:prstGeom prst="rect">
+            <a:avLst/>
+          </a:prstGeom>
+          <a:noFill/>
+          <a:ln/>
+        </p:spPr>
+        <p:txBody>
+          <a:bodyPr wrap="square" lIns="0" tIns="0" rIns="0" bIns="0" rtlCol="0" anchor="t">
+            <a:normAutofit/>
+          </a:bodyPr>
+          <a:lstStyle/>
+          <a:p>
+            <a:pPr algn="l" indent="0" marL="0">
+              <a:lnSpc>
+                <a:spcPts val="2160"/>
+              </a:lnSpc>
+              <a:buNone/>
+            </a:pPr>
+            <a:r>
+              <a:rPr lang="en-US" sz="1800" b="1" dirty="0">
+                <a:solidFill>
+                  <a:srgbClr val="5BA8E6"/>
+                </a:solidFill>
+                <a:latin typeface="Helvetica" pitchFamily="34" charset="0"/>
+                <a:ea typeface="Helvetica" pitchFamily="34" charset="-122"/>
+                <a:cs typeface="Helvetica" pitchFamily="34" charset="-120"/>
+              </a:rPr>
+              <a:t>O que aprendemos</a:t>
+            </a:r>
+            <a:endParaRPr lang="en-US" sz="1800" dirty="0"/>
+          </a:p>
+        </p:txBody>
+      </p:sp>
+      <p:sp>
+        <p:nvSpPr>
+          <p:cNvPr id="8" name="Text 6"/>
+          <p:cNvSpPr/>
+          <p:nvPr/>
+        </p:nvSpPr>
+        <p:spPr>
+          <a:xfrm>
+            <a:off x="4656667" y="2250442"/>
+            <a:ext cx="2965027" cy="1225550"/>
+          </a:xfrm>
+          <a:prstGeom prst="rect">
+            <a:avLst/>
+          </a:prstGeom>
+          <a:noFill/>
+          <a:ln/>
+        </p:spPr>
+        <p:txBody>
+          <a:bodyPr wrap="square" lIns="0" tIns="0" rIns="0" bIns="0" rtlCol="0" anchor="t">
+            <a:normAutofit/>
+          </a:bodyPr>
+          <a:lstStyle/>
+          <a:p>
+            <a:pPr algn="l" indent="0" marL="0">
+              <a:lnSpc>
+                <a:spcPts val="1890"/>
+              </a:lnSpc>
+              <a:buNone/>
+            </a:pPr>
+            <a:r>
+              <a:rPr lang="en-US" sz="1400" dirty="0">
+                <a:solidFill>
+                  <a:srgbClr val="F4F1EA"/>
+                </a:solidFill>
+                <a:latin typeface="Helvetica" pitchFamily="34" charset="0"/>
+                <a:ea typeface="Helvetica" pitchFamily="34" charset="-122"/>
+                <a:cs typeface="Helvetica" pitchFamily="34" charset="-120"/>
+              </a:rPr>
+              <a:t>Um LLM sem ferramenta estima números e erra com confiança. Isolamos a causa, adicionamos o nó verificador e passamos a calcular as cores sugeridas.</a:t>
+            </a:r>
+            <a:endParaRPr lang="en-US" sz="1400" dirty="0"/>
+          </a:p>
+        </p:txBody>
+      </p:sp>
+      <p:sp>
+        <p:nvSpPr>
+          <p:cNvPr id="9" name="Shape 7"/>
+          <p:cNvSpPr/>
+          <p:nvPr/>
+        </p:nvSpPr>
+        <p:spPr>
+          <a:xfrm>
+            <a:off x="7992533" y="1620521"/>
+            <a:ext cx="3386667" cy="2358390"/>
+          </a:xfrm>
+          <a:prstGeom prst="roundRect">
+            <a:avLst>
+              <a:gd name="adj" fmla="val 4308"/>
+            </a:avLst>
+          </a:prstGeom>
+          <a:solidFill>
+            <a:srgbClr val="1B2A41"/>
+          </a:solidFill>
+          <a:ln/>
+        </p:spPr>
+      </p:sp>
+      <p:sp>
+        <p:nvSpPr>
+          <p:cNvPr id="10" name="Text 8"/>
+          <p:cNvSpPr/>
+          <p:nvPr/>
+        </p:nvSpPr>
+        <p:spPr>
+          <a:xfrm>
+            <a:off x="8246533" y="1874521"/>
+            <a:ext cx="2965027" cy="574040"/>
+          </a:xfrm>
+          <a:prstGeom prst="rect">
+            <a:avLst/>
+          </a:prstGeom>
+          <a:noFill/>
+          <a:ln/>
+        </p:spPr>
+        <p:txBody>
+          <a:bodyPr wrap="square" lIns="0" tIns="0" rIns="0" bIns="0" rtlCol="0" anchor="t">
+            <a:normAutofit/>
+          </a:bodyPr>
+          <a:lstStyle/>
+          <a:p>
+            <a:pPr algn="l" indent="0" marL="0">
+              <a:lnSpc>
+                <a:spcPts val="2160"/>
+              </a:lnSpc>
+              <a:buNone/>
+            </a:pPr>
+            <a:r>
+              <a:rPr lang="en-US" sz="1800" b="1" dirty="0">
+                <a:solidFill>
+                  <a:srgbClr val="F2B84B"/>
+                </a:solidFill>
+                <a:latin typeface="Helvetica" pitchFamily="34" charset="0"/>
+                <a:ea typeface="Helvetica" pitchFamily="34" charset="-122"/>
+                <a:cs typeface="Helvetica" pitchFamily="34" charset="-120"/>
+              </a:rPr>
+              <a:t>Limites e próximos passos</a:t>
+            </a:r>
+            <a:endParaRPr lang="en-US" sz="1800" dirty="0"/>
+          </a:p>
+        </p:txBody>
+      </p:sp>
+      <p:sp>
+        <p:nvSpPr>
+          <p:cNvPr id="11" name="Text 9"/>
+          <p:cNvSpPr/>
+          <p:nvPr/>
+        </p:nvSpPr>
+        <p:spPr>
+          <a:xfrm>
+            <a:off x="8246533" y="2524758"/>
+            <a:ext cx="2965027" cy="1225550"/>
+          </a:xfrm>
+          <a:prstGeom prst="rect">
+            <a:avLst/>
+          </a:prstGeom>
+          <a:noFill/>
+          <a:ln/>
+        </p:spPr>
+        <p:txBody>
+          <a:bodyPr wrap="square" lIns="0" tIns="0" rIns="0" bIns="0" rtlCol="0" anchor="t">
+            <a:normAutofit/>
+          </a:bodyPr>
+          <a:lstStyle/>
+          <a:p>
+            <a:pPr algn="l" indent="0" marL="0">
+              <a:lnSpc>
+                <a:spcPts val="1890"/>
+              </a:lnSpc>
+              <a:buNone/>
+            </a:pPr>
+            <a:r>
+              <a:rPr lang="en-US" sz="1400" dirty="0">
+                <a:solidFill>
+                  <a:srgbClr val="F4F1EA"/>
+                </a:solidFill>
+                <a:latin typeface="Helvetica" pitchFamily="34" charset="0"/>
+                <a:ea typeface="Helvetica" pitchFamily="34" charset="-122"/>
+                <a:cs typeface="Helvetica" pitchFamily="34" charset="-120"/>
+              </a:rPr>
+              <a:t>Só avalia contraste de texto. O verificador depende de o Consultor seguir o formato SUGESTAO. Próximo passo: deixar o LLM decidir quando chamar a ferramenta.</a:t>
+            </a:r>
+            <a:endParaRPr lang="en-US" sz="1400" dirty="0"/>
           </a:p>
         </p:txBody>
       </p:sp>

</xml_diff>